<commit_message>
Redesign findings: card width now spans relevant process steps
Instead of separate colored connector bars above full-width cards,
each finding card's width now directly corresponds to the process
steps it covers — aligning left/right edges with the process flow.
Narrower cards stack title+description vertically; wider ones use
side-by-side layout.

https://claude.ai/code/session_018gqMj21S2CbNTMiwMALF8M
</commit_message>
<xml_diff>
--- a/P2P_Processkarta_Findings.pptx
+++ b/P2P_Processkarta_Findings.pptx
@@ -4293,23 +4293,27 @@
       </p:sp>
       <p:sp>
         <p:nvSpPr>
-          <p:cNvPr id="29" name="Oval 28"/>
+          <p:cNvPr id="29" name="Rounded Rectangle 28"/>
           <p:cNvSpPr/>
           <p:nvPr/>
         </p:nvSpPr>
         <p:spPr>
           <a:xfrm>
-            <a:off x="228600" y="2569464"/>
-            <a:ext cx="274320" cy="274320"/>
-          </a:xfrm>
-          <a:prstGeom prst="ellipse">
-            <a:avLst/>
+            <a:off x="609447" y="2240280"/>
+            <a:ext cx="3931920" cy="530352"/>
+          </a:xfrm>
+          <a:prstGeom prst="roundRect">
+            <a:avLst>
+              <a:gd name="adj" fmla="val 6000"/>
+            </a:avLst>
           </a:prstGeom>
           <a:solidFill>
-            <a:srgbClr val="E74C3C"/>
+            <a:srgbClr val="F2F2F2"/>
           </a:solidFill>
-          <a:ln>
-            <a:noFill/>
+          <a:ln w="15240">
+            <a:solidFill>
+              <a:srgbClr val="1B2A4A"/>
+            </a:solidFill>
           </a:ln>
         </p:spPr>
         <p:style>
@@ -4327,39 +4331,29 @@
           </a:fontRef>
         </p:style>
         <p:txBody>
-          <a:bodyPr rtlCol="0" anchor="ctr" lIns="0" rIns="0" tIns="0" bIns="0"/>
-          <a:lstStyle/>
-          <a:p>
-            <a:pPr algn="ctr">
-              <a:defRPr sz="900" b="1">
-                <a:solidFill>
-                  <a:srgbClr val="FFFFFF"/>
-                </a:solidFill>
-                <a:latin typeface="Calibri"/>
-              </a:defRPr>
-            </a:pPr>
-            <a:r>
-              <a:t>1</a:t>
-            </a:r>
-          </a:p>
-        </p:txBody>
-      </p:sp>
-      <p:sp>
-        <p:nvSpPr>
-          <p:cNvPr id="30" name="Rectangle 29"/>
+          <a:bodyPr rtlCol="0" anchor="ctr"/>
+          <a:lstStyle/>
+          <a:p>
+            <a:pPr algn="ctr"/>
+          </a:p>
+        </p:txBody>
+      </p:sp>
+      <p:sp>
+        <p:nvSpPr>
+          <p:cNvPr id="30" name="Oval 29"/>
           <p:cNvSpPr/>
           <p:nvPr/>
         </p:nvSpPr>
         <p:spPr>
           <a:xfrm>
-            <a:off x="609447" y="2423160"/>
-            <a:ext cx="3931920" cy="36576"/>
-          </a:xfrm>
-          <a:prstGeom prst="rect">
+            <a:off x="228600" y="2359152"/>
+            <a:ext cx="292608" cy="292608"/>
+          </a:xfrm>
+          <a:prstGeom prst="ellipse">
             <a:avLst/>
           </a:prstGeom>
           <a:solidFill>
-            <a:srgbClr val="E74C3C"/>
+            <a:srgbClr val="1B2A4A"/>
           </a:solidFill>
           <a:ln>
             <a:noFill/>
@@ -4380,32 +4374,118 @@
           </a:fontRef>
         </p:style>
         <p:txBody>
-          <a:bodyPr rtlCol="0" anchor="ctr"/>
-          <a:lstStyle/>
-          <a:p>
-            <a:pPr algn="ctr"/>
-          </a:p>
-        </p:txBody>
-      </p:sp>
-      <p:sp>
-        <p:nvSpPr>
-          <p:cNvPr id="31" name="Rectangle 30"/>
+          <a:bodyPr rtlCol="0" anchor="ctr" lIns="0" rIns="0" tIns="0" bIns="0"/>
+          <a:lstStyle/>
+          <a:p>
+            <a:pPr algn="ctr">
+              <a:defRPr sz="1000" b="1">
+                <a:solidFill>
+                  <a:srgbClr val="FFFFFF"/>
+                </a:solidFill>
+                <a:latin typeface="Calibri"/>
+              </a:defRPr>
+            </a:pPr>
+            <a:r>
+              <a:t>1</a:t>
+            </a:r>
+          </a:p>
+        </p:txBody>
+      </p:sp>
+      <p:sp>
+        <p:nvSpPr>
+          <p:cNvPr id="31" name="TextBox 30"/>
+          <p:cNvSpPr txBox="1"/>
+          <p:nvPr/>
+        </p:nvSpPr>
+        <p:spPr>
+          <a:xfrm>
+            <a:off x="746607" y="2295144"/>
+            <a:ext cx="1376172" cy="420624"/>
+          </a:xfrm>
+          <a:prstGeom prst="rect">
+            <a:avLst/>
+          </a:prstGeom>
+          <a:noFill/>
+        </p:spPr>
+        <p:txBody>
+          <a:bodyPr wrap="square">
+            <a:spAutoFit/>
+          </a:bodyPr>
+          <a:lstStyle/>
+          <a:p>
+            <a:pPr algn="l">
+              <a:defRPr sz="900" b="1">
+                <a:solidFill>
+                  <a:srgbClr val="1B2A4A"/>
+                </a:solidFill>
+                <a:latin typeface="Calibri"/>
+              </a:defRPr>
+            </a:pPr>
+            <a:r>
+              <a:t>Ingen styrd väg från behov till köp</a:t>
+            </a:r>
+          </a:p>
+        </p:txBody>
+      </p:sp>
+      <p:sp>
+        <p:nvSpPr>
+          <p:cNvPr id="32" name="TextBox 31"/>
+          <p:cNvSpPr txBox="1"/>
+          <p:nvPr/>
+        </p:nvSpPr>
+        <p:spPr>
+          <a:xfrm>
+            <a:off x="2259939" y="2295144"/>
+            <a:ext cx="2144268" cy="420624"/>
+          </a:xfrm>
+          <a:prstGeom prst="rect">
+            <a:avLst/>
+          </a:prstGeom>
+          <a:noFill/>
+        </p:spPr>
+        <p:txBody>
+          <a:bodyPr wrap="square">
+            <a:spAutoFit/>
+          </a:bodyPr>
+          <a:lstStyle/>
+          <a:p>
+            <a:pPr algn="l">
+              <a:defRPr sz="800" b="0">
+                <a:solidFill>
+                  <a:srgbClr val="666666"/>
+                </a:solidFill>
+                <a:latin typeface="Calibri"/>
+              </a:defRPr>
+            </a:pPr>
+            <a:r>
+              <a:t>Det finns en ingång för behov, men inte ett styrt beställningsflöde som leder till rätt leverantör, rätt avtal och rätt pris.</a:t>
+            </a:r>
+          </a:p>
+        </p:txBody>
+      </p:sp>
+      <p:sp>
+        <p:nvSpPr>
+          <p:cNvPr id="33" name="Rounded Rectangle 32"/>
           <p:cNvSpPr/>
           <p:nvPr/>
         </p:nvSpPr>
         <p:spPr>
           <a:xfrm>
-            <a:off x="609447" y="2395728"/>
-            <a:ext cx="25400" cy="91440"/>
-          </a:xfrm>
-          <a:prstGeom prst="rect">
-            <a:avLst/>
+            <a:off x="2017623" y="2843784"/>
+            <a:ext cx="2523744" cy="530352"/>
+          </a:xfrm>
+          <a:prstGeom prst="roundRect">
+            <a:avLst>
+              <a:gd name="adj" fmla="val 6000"/>
+            </a:avLst>
           </a:prstGeom>
           <a:solidFill>
-            <a:srgbClr val="E74C3C"/>
+            <a:srgbClr val="F2F2F2"/>
           </a:solidFill>
-          <a:ln>
-            <a:noFill/>
+          <a:ln w="15240">
+            <a:solidFill>
+              <a:srgbClr val="1B2A4A"/>
+            </a:solidFill>
           </a:ln>
         </p:spPr>
         <p:style>
@@ -4432,20 +4512,20 @@
       </p:sp>
       <p:sp>
         <p:nvSpPr>
-          <p:cNvPr id="32" name="Rectangle 31"/>
+          <p:cNvPr id="34" name="Oval 33"/>
           <p:cNvSpPr/>
           <p:nvPr/>
         </p:nvSpPr>
         <p:spPr>
           <a:xfrm>
-            <a:off x="4515967" y="2395728"/>
-            <a:ext cx="25400" cy="91440"/>
-          </a:xfrm>
-          <a:prstGeom prst="rect">
+            <a:off x="228600" y="2962656"/>
+            <a:ext cx="292608" cy="292608"/>
+          </a:xfrm>
+          <a:prstGeom prst="ellipse">
             <a:avLst/>
           </a:prstGeom>
           <a:solidFill>
-            <a:srgbClr val="E74C3C"/>
+            <a:srgbClr val="1B2A4A"/>
           </a:solidFill>
           <a:ln>
             <a:noFill/>
@@ -4466,23 +4546,85 @@
           </a:fontRef>
         </p:style>
         <p:txBody>
-          <a:bodyPr rtlCol="0" anchor="ctr"/>
-          <a:lstStyle/>
-          <a:p>
-            <a:pPr algn="ctr"/>
-          </a:p>
-        </p:txBody>
-      </p:sp>
-      <p:sp>
-        <p:nvSpPr>
-          <p:cNvPr id="33" name="Rounded Rectangle 32"/>
+          <a:bodyPr rtlCol="0" anchor="ctr" lIns="0" rIns="0" tIns="0" bIns="0"/>
+          <a:lstStyle/>
+          <a:p>
+            <a:pPr algn="ctr">
+              <a:defRPr sz="1000" b="1">
+                <a:solidFill>
+                  <a:srgbClr val="FFFFFF"/>
+                </a:solidFill>
+                <a:latin typeface="Calibri"/>
+              </a:defRPr>
+            </a:pPr>
+            <a:r>
+              <a:t>2</a:t>
+            </a:r>
+          </a:p>
+        </p:txBody>
+      </p:sp>
+      <p:sp>
+        <p:nvSpPr>
+          <p:cNvPr id="35" name="TextBox 34"/>
+          <p:cNvSpPr txBox="1"/>
+          <p:nvPr/>
+        </p:nvSpPr>
+        <p:spPr>
+          <a:xfrm>
+            <a:off x="2154783" y="2898648"/>
+            <a:ext cx="2249424" cy="420624"/>
+          </a:xfrm>
+          <a:prstGeom prst="rect">
+            <a:avLst/>
+          </a:prstGeom>
+          <a:noFill/>
+        </p:spPr>
+        <p:txBody>
+          <a:bodyPr wrap="square">
+            <a:spAutoFit/>
+          </a:bodyPr>
+          <a:lstStyle/>
+          <a:p>
+            <a:pPr>
+              <a:spcAft>
+                <a:spcPts val="200"/>
+              </a:spcAft>
+              <a:defRPr sz="900" b="1">
+                <a:solidFill>
+                  <a:srgbClr val="1B2A4A"/>
+                </a:solidFill>
+                <a:latin typeface="Calibri"/>
+              </a:defRPr>
+            </a:pPr>
+            <a:r>
+              <a:t>Svagt stöd för köp på avtal</a:t>
+            </a:r>
+          </a:p>
+          <a:p>
+            <a:pPr>
+              <a:defRPr sz="750">
+                <a:solidFill>
+                  <a:srgbClr val="666666"/>
+                </a:solidFill>
+                <a:latin typeface="Calibri"/>
+              </a:defRPr>
+            </a:pPr>
+            <a:r>
+              <a:t>Det är svårt att hitta och använda rätt avtal i vardagen, vilket driver köp utanför avtal.</a:t>
+            </a:r>
+          </a:p>
+        </p:txBody>
+      </p:sp>
+      <p:sp>
+        <p:nvSpPr>
+          <p:cNvPr id="36" name="Rounded Rectangle 35"/>
           <p:cNvSpPr/>
           <p:nvPr/>
         </p:nvSpPr>
         <p:spPr>
           <a:xfrm>
-            <a:off x="594360" y="2478024"/>
-            <a:ext cx="10972800" cy="493776"/>
+            <a:off x="2017623" y="3447288"/>
+            <a:ext cx="9564624" cy="530352"/>
           </a:xfrm>
           <a:prstGeom prst="roundRect">
             <a:avLst>
@@ -4492,9 +4634,9 @@
           <a:solidFill>
             <a:srgbClr val="F2F2F2"/>
           </a:solidFill>
-          <a:ln w="6350">
+          <a:ln w="15240">
             <a:solidFill>
-              <a:srgbClr val="D5DBE1"/>
+              <a:srgbClr val="1B2A4A"/>
             </a:solidFill>
           </a:ln>
         </p:spPr>
@@ -4522,92 +4664,20 @@
       </p:sp>
       <p:sp>
         <p:nvSpPr>
-          <p:cNvPr id="34" name="TextBox 33"/>
-          <p:cNvSpPr txBox="1"/>
-          <p:nvPr/>
-        </p:nvSpPr>
-        <p:spPr>
-          <a:xfrm>
-            <a:off x="731520" y="2514600"/>
-            <a:ext cx="3474720" cy="420624"/>
-          </a:xfrm>
-          <a:prstGeom prst="rect">
-            <a:avLst/>
-          </a:prstGeom>
-          <a:noFill/>
-        </p:spPr>
-        <p:txBody>
-          <a:bodyPr wrap="square">
-            <a:spAutoFit/>
-          </a:bodyPr>
-          <a:lstStyle/>
-          <a:p>
-            <a:pPr algn="l">
-              <a:defRPr sz="900" b="1">
-                <a:solidFill>
-                  <a:srgbClr val="1B2A4A"/>
-                </a:solidFill>
-                <a:latin typeface="Calibri"/>
-              </a:defRPr>
-            </a:pPr>
-            <a:r>
-              <a:t>Ingen styrd väg från behov till köp</a:t>
-            </a:r>
-          </a:p>
-        </p:txBody>
-      </p:sp>
-      <p:sp>
-        <p:nvSpPr>
-          <p:cNvPr id="35" name="TextBox 34"/>
-          <p:cNvSpPr txBox="1"/>
-          <p:nvPr/>
-        </p:nvSpPr>
-        <p:spPr>
-          <a:xfrm>
-            <a:off x="4297680" y="2514600"/>
-            <a:ext cx="7086600" cy="420624"/>
-          </a:xfrm>
-          <a:prstGeom prst="rect">
-            <a:avLst/>
-          </a:prstGeom>
-          <a:noFill/>
-        </p:spPr>
-        <p:txBody>
-          <a:bodyPr wrap="square">
-            <a:spAutoFit/>
-          </a:bodyPr>
-          <a:lstStyle/>
-          <a:p>
-            <a:pPr algn="l">
-              <a:defRPr sz="800" b="0">
-                <a:solidFill>
-                  <a:srgbClr val="666666"/>
-                </a:solidFill>
-                <a:latin typeface="Calibri"/>
-              </a:defRPr>
-            </a:pPr>
-            <a:r>
-              <a:t>Det finns en ingång för behov, men inte ett styrt beställningsflöde som leder till rätt leverantör, rätt avtal och rätt pris.</a:t>
-            </a:r>
-          </a:p>
-        </p:txBody>
-      </p:sp>
-      <p:sp>
-        <p:nvSpPr>
-          <p:cNvPr id="36" name="Oval 35"/>
+          <p:cNvPr id="37" name="Oval 36"/>
           <p:cNvSpPr/>
           <p:nvPr/>
         </p:nvSpPr>
         <p:spPr>
           <a:xfrm>
-            <a:off x="228600" y="3209544"/>
-            <a:ext cx="274320" cy="274320"/>
+            <a:off x="228600" y="3566160"/>
+            <a:ext cx="292608" cy="292608"/>
           </a:xfrm>
           <a:prstGeom prst="ellipse">
             <a:avLst/>
           </a:prstGeom>
           <a:solidFill>
-            <a:srgbClr val="E76F51"/>
+            <a:srgbClr val="1B2A4A"/>
           </a:solidFill>
           <a:ln>
             <a:noFill/>
@@ -4632,38 +4702,114 @@
           <a:lstStyle/>
           <a:p>
             <a:pPr algn="ctr">
+              <a:defRPr sz="1000" b="1">
+                <a:solidFill>
+                  <a:srgbClr val="FFFFFF"/>
+                </a:solidFill>
+                <a:latin typeface="Calibri"/>
+              </a:defRPr>
+            </a:pPr>
+            <a:r>
+              <a:t>3</a:t>
+            </a:r>
+          </a:p>
+        </p:txBody>
+      </p:sp>
+      <p:sp>
+        <p:nvSpPr>
+          <p:cNvPr id="38" name="TextBox 37"/>
+          <p:cNvSpPr txBox="1"/>
+          <p:nvPr/>
+        </p:nvSpPr>
+        <p:spPr>
+          <a:xfrm>
+            <a:off x="2154783" y="3502152"/>
+            <a:ext cx="3291840" cy="420624"/>
+          </a:xfrm>
+          <a:prstGeom prst="rect">
+            <a:avLst/>
+          </a:prstGeom>
+          <a:noFill/>
+        </p:spPr>
+        <p:txBody>
+          <a:bodyPr wrap="square">
+            <a:spAutoFit/>
+          </a:bodyPr>
+          <a:lstStyle/>
+          <a:p>
+            <a:pPr algn="l">
               <a:defRPr sz="900" b="1">
                 <a:solidFill>
-                  <a:srgbClr val="FFFFFF"/>
+                  <a:srgbClr val="1B2A4A"/>
                 </a:solidFill>
                 <a:latin typeface="Calibri"/>
               </a:defRPr>
             </a:pPr>
             <a:r>
-              <a:t>2</a:t>
-            </a:r>
-          </a:p>
-        </p:txBody>
-      </p:sp>
-      <p:sp>
-        <p:nvSpPr>
-          <p:cNvPr id="37" name="Rectangle 36"/>
+              <a:t>Splittrad avtals- och leverantörsinformation</a:t>
+            </a:r>
+          </a:p>
+        </p:txBody>
+      </p:sp>
+      <p:sp>
+        <p:nvSpPr>
+          <p:cNvPr id="39" name="TextBox 38"/>
+          <p:cNvSpPr txBox="1"/>
+          <p:nvPr/>
+        </p:nvSpPr>
+        <p:spPr>
+          <a:xfrm>
+            <a:off x="5583783" y="3502152"/>
+            <a:ext cx="5861304" cy="420624"/>
+          </a:xfrm>
+          <a:prstGeom prst="rect">
+            <a:avLst/>
+          </a:prstGeom>
+          <a:noFill/>
+        </p:spPr>
+        <p:txBody>
+          <a:bodyPr wrap="square">
+            <a:spAutoFit/>
+          </a:bodyPr>
+          <a:lstStyle/>
+          <a:p>
+            <a:pPr algn="l">
+              <a:defRPr sz="800" b="0">
+                <a:solidFill>
+                  <a:srgbClr val="666666"/>
+                </a:solidFill>
+                <a:latin typeface="Calibri"/>
+              </a:defRPr>
+            </a:pPr>
+            <a:r>
+              <a:t>Ingen sammanhållen koppling mellan inköp, avtal och ekonomi försvårar spårbarhet och uppföljning.</a:t>
+            </a:r>
+          </a:p>
+        </p:txBody>
+      </p:sp>
+      <p:sp>
+        <p:nvSpPr>
+          <p:cNvPr id="40" name="Rounded Rectangle 39"/>
           <p:cNvSpPr/>
           <p:nvPr/>
         </p:nvSpPr>
         <p:spPr>
           <a:xfrm>
-            <a:off x="2017623" y="3063240"/>
-            <a:ext cx="2523744" cy="36576"/>
-          </a:xfrm>
-          <a:prstGeom prst="rect">
-            <a:avLst/>
+            <a:off x="3425799" y="4050792"/>
+            <a:ext cx="6748272" cy="530352"/>
+          </a:xfrm>
+          <a:prstGeom prst="roundRect">
+            <a:avLst>
+              <a:gd name="adj" fmla="val 6000"/>
+            </a:avLst>
           </a:prstGeom>
           <a:solidFill>
-            <a:srgbClr val="E76F51"/>
+            <a:srgbClr val="F2F2F2"/>
           </a:solidFill>
-          <a:ln>
-            <a:noFill/>
+          <a:ln w="15240">
+            <a:solidFill>
+              <a:srgbClr val="1B2A4A"/>
+            </a:solidFill>
           </a:ln>
         </p:spPr>
         <p:style>
@@ -4690,20 +4836,20 @@
       </p:sp>
       <p:sp>
         <p:nvSpPr>
-          <p:cNvPr id="38" name="Rectangle 37"/>
+          <p:cNvPr id="41" name="Oval 40"/>
           <p:cNvSpPr/>
           <p:nvPr/>
         </p:nvSpPr>
         <p:spPr>
           <a:xfrm>
-            <a:off x="2017623" y="3035808"/>
-            <a:ext cx="25400" cy="91440"/>
-          </a:xfrm>
-          <a:prstGeom prst="rect">
+            <a:off x="228600" y="4169664"/>
+            <a:ext cx="292608" cy="292608"/>
+          </a:xfrm>
+          <a:prstGeom prst="ellipse">
             <a:avLst/>
           </a:prstGeom>
           <a:solidFill>
-            <a:srgbClr val="E76F51"/>
+            <a:srgbClr val="1B2A4A"/>
           </a:solidFill>
           <a:ln>
             <a:noFill/>
@@ -4724,32 +4870,118 @@
           </a:fontRef>
         </p:style>
         <p:txBody>
-          <a:bodyPr rtlCol="0" anchor="ctr"/>
-          <a:lstStyle/>
-          <a:p>
-            <a:pPr algn="ctr"/>
-          </a:p>
-        </p:txBody>
-      </p:sp>
-      <p:sp>
-        <p:nvSpPr>
-          <p:cNvPr id="39" name="Rectangle 38"/>
+          <a:bodyPr rtlCol="0" anchor="ctr" lIns="0" rIns="0" tIns="0" bIns="0"/>
+          <a:lstStyle/>
+          <a:p>
+            <a:pPr algn="ctr">
+              <a:defRPr sz="1000" b="1">
+                <a:solidFill>
+                  <a:srgbClr val="FFFFFF"/>
+                </a:solidFill>
+                <a:latin typeface="Calibri"/>
+              </a:defRPr>
+            </a:pPr>
+            <a:r>
+              <a:t>4</a:t>
+            </a:r>
+          </a:p>
+        </p:txBody>
+      </p:sp>
+      <p:sp>
+        <p:nvSpPr>
+          <p:cNvPr id="42" name="TextBox 41"/>
+          <p:cNvSpPr txBox="1"/>
+          <p:nvPr/>
+        </p:nvSpPr>
+        <p:spPr>
+          <a:xfrm>
+            <a:off x="3562959" y="4105656"/>
+            <a:ext cx="2361895" cy="420624"/>
+          </a:xfrm>
+          <a:prstGeom prst="rect">
+            <a:avLst/>
+          </a:prstGeom>
+          <a:noFill/>
+        </p:spPr>
+        <p:txBody>
+          <a:bodyPr wrap="square">
+            <a:spAutoFit/>
+          </a:bodyPr>
+          <a:lstStyle/>
+          <a:p>
+            <a:pPr algn="l">
+              <a:defRPr sz="900" b="1">
+                <a:solidFill>
+                  <a:srgbClr val="1B2A4A"/>
+                </a:solidFill>
+                <a:latin typeface="Calibri"/>
+              </a:defRPr>
+            </a:pPr>
+            <a:r>
+              <a:t>Manuella och svårt överblickbara arbetsflöden</a:t>
+            </a:r>
+          </a:p>
+        </p:txBody>
+      </p:sp>
+      <p:sp>
+        <p:nvSpPr>
+          <p:cNvPr id="43" name="TextBox 42"/>
+          <p:cNvSpPr txBox="1"/>
+          <p:nvPr/>
+        </p:nvSpPr>
+        <p:spPr>
+          <a:xfrm>
+            <a:off x="6062014" y="4105656"/>
+            <a:ext cx="3974896" cy="420624"/>
+          </a:xfrm>
+          <a:prstGeom prst="rect">
+            <a:avLst/>
+          </a:prstGeom>
+          <a:noFill/>
+        </p:spPr>
+        <p:txBody>
+          <a:bodyPr wrap="square">
+            <a:spAutoFit/>
+          </a:bodyPr>
+          <a:lstStyle/>
+          <a:p>
+            <a:pPr algn="l">
+              <a:defRPr sz="800" b="0">
+                <a:solidFill>
+                  <a:srgbClr val="666666"/>
+                </a:solidFill>
+                <a:latin typeface="Calibri"/>
+              </a:defRPr>
+            </a:pPr>
+            <a:r>
+              <a:t>Excel, mejl, Teams och personberoende arbetssätt försvårar översikt, status och skalbarhet.</a:t>
+            </a:r>
+          </a:p>
+        </p:txBody>
+      </p:sp>
+      <p:sp>
+        <p:nvSpPr>
+          <p:cNvPr id="44" name="Rounded Rectangle 43"/>
           <p:cNvSpPr/>
           <p:nvPr/>
         </p:nvSpPr>
         <p:spPr>
           <a:xfrm>
-            <a:off x="4515967" y="3035808"/>
-            <a:ext cx="25400" cy="91440"/>
-          </a:xfrm>
-          <a:prstGeom prst="rect">
-            <a:avLst/>
+            <a:off x="4833975" y="4654296"/>
+            <a:ext cx="6748272" cy="530352"/>
+          </a:xfrm>
+          <a:prstGeom prst="roundRect">
+            <a:avLst>
+              <a:gd name="adj" fmla="val 6000"/>
+            </a:avLst>
           </a:prstGeom>
           <a:solidFill>
-            <a:srgbClr val="E76F51"/>
+            <a:srgbClr val="F2F2F2"/>
           </a:solidFill>
-          <a:ln>
-            <a:noFill/>
+          <a:ln w="15240">
+            <a:solidFill>
+              <a:srgbClr val="1B2A4A"/>
+            </a:solidFill>
           </a:ln>
         </p:spPr>
         <p:style>
@@ -4776,27 +5008,23 @@
       </p:sp>
       <p:sp>
         <p:nvSpPr>
-          <p:cNvPr id="40" name="Rounded Rectangle 39"/>
+          <p:cNvPr id="45" name="Oval 44"/>
           <p:cNvSpPr/>
           <p:nvPr/>
         </p:nvSpPr>
         <p:spPr>
           <a:xfrm>
-            <a:off x="594360" y="3118104"/>
-            <a:ext cx="10972800" cy="493776"/>
-          </a:xfrm>
-          <a:prstGeom prst="roundRect">
-            <a:avLst>
-              <a:gd name="adj" fmla="val 6000"/>
-            </a:avLst>
+            <a:off x="228600" y="4773168"/>
+            <a:ext cx="292608" cy="292608"/>
+          </a:xfrm>
+          <a:prstGeom prst="ellipse">
+            <a:avLst/>
           </a:prstGeom>
           <a:solidFill>
-            <a:srgbClr val="F2F2F2"/>
+            <a:srgbClr val="1B2A4A"/>
           </a:solidFill>
-          <a:ln w="6350">
-            <a:solidFill>
-              <a:srgbClr val="D5DBE1"/>
-            </a:solidFill>
+          <a:ln>
+            <a:noFill/>
           </a:ln>
         </p:spPr>
         <p:style>
@@ -4814,23 +5042,33 @@
           </a:fontRef>
         </p:style>
         <p:txBody>
-          <a:bodyPr rtlCol="0" anchor="ctr"/>
-          <a:lstStyle/>
-          <a:p>
-            <a:pPr algn="ctr"/>
-          </a:p>
-        </p:txBody>
-      </p:sp>
-      <p:sp>
-        <p:nvSpPr>
-          <p:cNvPr id="41" name="TextBox 40"/>
+          <a:bodyPr rtlCol="0" anchor="ctr" lIns="0" rIns="0" tIns="0" bIns="0"/>
+          <a:lstStyle/>
+          <a:p>
+            <a:pPr algn="ctr">
+              <a:defRPr sz="1000" b="1">
+                <a:solidFill>
+                  <a:srgbClr val="FFFFFF"/>
+                </a:solidFill>
+                <a:latin typeface="Calibri"/>
+              </a:defRPr>
+            </a:pPr>
+            <a:r>
+              <a:t>5</a:t>
+            </a:r>
+          </a:p>
+        </p:txBody>
+      </p:sp>
+      <p:sp>
+        <p:nvSpPr>
+          <p:cNvPr id="46" name="TextBox 45"/>
           <p:cNvSpPr txBox="1"/>
           <p:nvPr/>
         </p:nvSpPr>
         <p:spPr>
           <a:xfrm>
-            <a:off x="731520" y="3154680"/>
-            <a:ext cx="3474720" cy="420624"/>
+            <a:off x="4971135" y="4709160"/>
+            <a:ext cx="2361895" cy="420624"/>
           </a:xfrm>
           <a:prstGeom prst="rect">
             <a:avLst/>
@@ -4852,21 +5090,21 @@
               </a:defRPr>
             </a:pPr>
             <a:r>
-              <a:t>Svagt stöd för köp på avtal</a:t>
-            </a:r>
-          </a:p>
-        </p:txBody>
-      </p:sp>
-      <p:sp>
-        <p:nvSpPr>
-          <p:cNvPr id="42" name="TextBox 41"/>
+              <a:t>Otydliga ansvar och varierande arbetssätt</a:t>
+            </a:r>
+          </a:p>
+        </p:txBody>
+      </p:sp>
+      <p:sp>
+        <p:nvSpPr>
+          <p:cNvPr id="47" name="TextBox 46"/>
           <p:cNvSpPr txBox="1"/>
           <p:nvPr/>
         </p:nvSpPr>
         <p:spPr>
           <a:xfrm>
-            <a:off x="4297680" y="3154680"/>
-            <a:ext cx="7086600" cy="420624"/>
+            <a:off x="7470190" y="4709160"/>
+            <a:ext cx="3974896" cy="420624"/>
           </a:xfrm>
           <a:prstGeom prst="rect">
             <a:avLst/>
@@ -4888,30 +5126,34 @@
               </a:defRPr>
             </a:pPr>
             <a:r>
-              <a:t>Det är svårt att hitta och använda rätt avtal i vardagen, vilket driver köp utanför avtal.</a:t>
-            </a:r>
-          </a:p>
-        </p:txBody>
-      </p:sp>
-      <p:sp>
-        <p:nvSpPr>
-          <p:cNvPr id="43" name="Oval 42"/>
+              <a:t>Roller arbetar olika och ansvar är inte alltid tydligt definierade, vilket försvårar återkoppling och konsekvent hantering.</a:t>
+            </a:r>
+          </a:p>
+        </p:txBody>
+      </p:sp>
+      <p:sp>
+        <p:nvSpPr>
+          <p:cNvPr id="48" name="Rounded Rectangle 47"/>
           <p:cNvSpPr/>
           <p:nvPr/>
         </p:nvSpPr>
         <p:spPr>
           <a:xfrm>
-            <a:off x="228600" y="3849624"/>
-            <a:ext cx="274320" cy="274320"/>
-          </a:xfrm>
-          <a:prstGeom prst="ellipse">
-            <a:avLst/>
+            <a:off x="6242151" y="5257800"/>
+            <a:ext cx="5340096" cy="530352"/>
+          </a:xfrm>
+          <a:prstGeom prst="roundRect">
+            <a:avLst>
+              <a:gd name="adj" fmla="val 6000"/>
+            </a:avLst>
           </a:prstGeom>
           <a:solidFill>
-            <a:srgbClr val="F0844D"/>
+            <a:srgbClr val="F2F2F2"/>
           </a:solidFill>
-          <a:ln>
-            <a:noFill/>
+          <a:ln w="15240">
+            <a:solidFill>
+              <a:srgbClr val="1B2A4A"/>
+            </a:solidFill>
           </a:ln>
         </p:spPr>
         <p:style>
@@ -4929,39 +5171,29 @@
           </a:fontRef>
         </p:style>
         <p:txBody>
-          <a:bodyPr rtlCol="0" anchor="ctr" lIns="0" rIns="0" tIns="0" bIns="0"/>
-          <a:lstStyle/>
-          <a:p>
-            <a:pPr algn="ctr">
-              <a:defRPr sz="900" b="1">
-                <a:solidFill>
-                  <a:srgbClr val="FFFFFF"/>
-                </a:solidFill>
-                <a:latin typeface="Calibri"/>
-              </a:defRPr>
-            </a:pPr>
-            <a:r>
-              <a:t>3</a:t>
-            </a:r>
-          </a:p>
-        </p:txBody>
-      </p:sp>
-      <p:sp>
-        <p:nvSpPr>
-          <p:cNvPr id="44" name="Rectangle 43"/>
+          <a:bodyPr rtlCol="0" anchor="ctr"/>
+          <a:lstStyle/>
+          <a:p>
+            <a:pPr algn="ctr"/>
+          </a:p>
+        </p:txBody>
+      </p:sp>
+      <p:sp>
+        <p:nvSpPr>
+          <p:cNvPr id="49" name="Oval 48"/>
           <p:cNvSpPr/>
           <p:nvPr/>
         </p:nvSpPr>
         <p:spPr>
           <a:xfrm>
-            <a:off x="2017623" y="3703320"/>
-            <a:ext cx="9564624" cy="36576"/>
-          </a:xfrm>
-          <a:prstGeom prst="rect">
+            <a:off x="228600" y="5376672"/>
+            <a:ext cx="292608" cy="292608"/>
+          </a:xfrm>
+          <a:prstGeom prst="ellipse">
             <a:avLst/>
           </a:prstGeom>
           <a:solidFill>
-            <a:srgbClr val="F0844D"/>
+            <a:srgbClr val="1B2A4A"/>
           </a:solidFill>
           <a:ln>
             <a:noFill/>
@@ -4982,32 +5214,118 @@
           </a:fontRef>
         </p:style>
         <p:txBody>
-          <a:bodyPr rtlCol="0" anchor="ctr"/>
-          <a:lstStyle/>
-          <a:p>
-            <a:pPr algn="ctr"/>
-          </a:p>
-        </p:txBody>
-      </p:sp>
-      <p:sp>
-        <p:nvSpPr>
-          <p:cNvPr id="45" name="Rectangle 44"/>
+          <a:bodyPr rtlCol="0" anchor="ctr" lIns="0" rIns="0" tIns="0" bIns="0"/>
+          <a:lstStyle/>
+          <a:p>
+            <a:pPr algn="ctr">
+              <a:defRPr sz="1000" b="1">
+                <a:solidFill>
+                  <a:srgbClr val="FFFFFF"/>
+                </a:solidFill>
+                <a:latin typeface="Calibri"/>
+              </a:defRPr>
+            </a:pPr>
+            <a:r>
+              <a:t>6</a:t>
+            </a:r>
+          </a:p>
+        </p:txBody>
+      </p:sp>
+      <p:sp>
+        <p:nvSpPr>
+          <p:cNvPr id="50" name="TextBox 49"/>
+          <p:cNvSpPr txBox="1"/>
+          <p:nvPr/>
+        </p:nvSpPr>
+        <p:spPr>
+          <a:xfrm>
+            <a:off x="6379311" y="5312664"/>
+            <a:ext cx="1869033" cy="420624"/>
+          </a:xfrm>
+          <a:prstGeom prst="rect">
+            <a:avLst/>
+          </a:prstGeom>
+          <a:noFill/>
+        </p:spPr>
+        <p:txBody>
+          <a:bodyPr wrap="square">
+            <a:spAutoFit/>
+          </a:bodyPr>
+          <a:lstStyle/>
+          <a:p>
+            <a:pPr algn="l">
+              <a:defRPr sz="900" b="1">
+                <a:solidFill>
+                  <a:srgbClr val="1B2A4A"/>
+                </a:solidFill>
+                <a:latin typeface="Calibri"/>
+              </a:defRPr>
+            </a:pPr>
+            <a:r>
+              <a:t>Kontrollen kommer först vid fakturan</a:t>
+            </a:r>
+          </a:p>
+        </p:txBody>
+      </p:sp>
+      <p:sp>
+        <p:nvSpPr>
+          <p:cNvPr id="51" name="TextBox 50"/>
+          <p:cNvSpPr txBox="1"/>
+          <p:nvPr/>
+        </p:nvSpPr>
+        <p:spPr>
+          <a:xfrm>
+            <a:off x="8385505" y="5312664"/>
+            <a:ext cx="3059582" cy="420624"/>
+          </a:xfrm>
+          <a:prstGeom prst="rect">
+            <a:avLst/>
+          </a:prstGeom>
+          <a:noFill/>
+        </p:spPr>
+        <p:txBody>
+          <a:bodyPr wrap="square">
+            <a:spAutoFit/>
+          </a:bodyPr>
+          <a:lstStyle/>
+          <a:p>
+            <a:pPr algn="l">
+              <a:defRPr sz="800" b="0">
+                <a:solidFill>
+                  <a:srgbClr val="666666"/>
+                </a:solidFill>
+                <a:latin typeface="Calibri"/>
+              </a:defRPr>
+            </a:pPr>
+            <a:r>
+              <a:t>Avvikelser och fel upptäcks sent, vilket gör kontrollen reaktiv och försvårar internkontroll och tidig felupptäckt.</a:t>
+            </a:r>
+          </a:p>
+        </p:txBody>
+      </p:sp>
+      <p:sp>
+        <p:nvSpPr>
+          <p:cNvPr id="52" name="Rounded Rectangle 51"/>
           <p:cNvSpPr/>
           <p:nvPr/>
         </p:nvSpPr>
         <p:spPr>
           <a:xfrm>
-            <a:off x="2017623" y="3675888"/>
-            <a:ext cx="25400" cy="91440"/>
-          </a:xfrm>
-          <a:prstGeom prst="rect">
-            <a:avLst/>
+            <a:off x="10466679" y="5861304"/>
+            <a:ext cx="1115568" cy="530352"/>
+          </a:xfrm>
+          <a:prstGeom prst="roundRect">
+            <a:avLst>
+              <a:gd name="adj" fmla="val 6000"/>
+            </a:avLst>
           </a:prstGeom>
           <a:solidFill>
-            <a:srgbClr val="F0844D"/>
+            <a:srgbClr val="F2F2F2"/>
           </a:solidFill>
-          <a:ln>
-            <a:noFill/>
+          <a:ln w="15240">
+            <a:solidFill>
+              <a:srgbClr val="1B2A4A"/>
+            </a:solidFill>
           </a:ln>
         </p:spPr>
         <p:style>
@@ -5034,20 +5352,20 @@
       </p:sp>
       <p:sp>
         <p:nvSpPr>
-          <p:cNvPr id="46" name="Rectangle 45"/>
+          <p:cNvPr id="53" name="Oval 52"/>
           <p:cNvSpPr/>
           <p:nvPr/>
         </p:nvSpPr>
         <p:spPr>
           <a:xfrm>
-            <a:off x="11556847" y="3675888"/>
-            <a:ext cx="25400" cy="91440"/>
-          </a:xfrm>
-          <a:prstGeom prst="rect">
+            <a:off x="228600" y="5980176"/>
+            <a:ext cx="292608" cy="292608"/>
+          </a:xfrm>
+          <a:prstGeom prst="ellipse">
             <a:avLst/>
           </a:prstGeom>
           <a:solidFill>
-            <a:srgbClr val="F0844D"/>
+            <a:srgbClr val="1B2A4A"/>
           </a:solidFill>
           <a:ln>
             <a:noFill/>
@@ -5068,70 +5386,33 @@
           </a:fontRef>
         </p:style>
         <p:txBody>
-          <a:bodyPr rtlCol="0" anchor="ctr"/>
-          <a:lstStyle/>
-          <a:p>
-            <a:pPr algn="ctr"/>
-          </a:p>
-        </p:txBody>
-      </p:sp>
-      <p:sp>
-        <p:nvSpPr>
-          <p:cNvPr id="47" name="Rounded Rectangle 46"/>
-          <p:cNvSpPr/>
-          <p:nvPr/>
-        </p:nvSpPr>
-        <p:spPr>
-          <a:xfrm>
-            <a:off x="594360" y="3758184"/>
-            <a:ext cx="10972800" cy="493776"/>
-          </a:xfrm>
-          <a:prstGeom prst="roundRect">
-            <a:avLst>
-              <a:gd name="adj" fmla="val 6000"/>
-            </a:avLst>
-          </a:prstGeom>
-          <a:solidFill>
-            <a:srgbClr val="F2F2F2"/>
-          </a:solidFill>
-          <a:ln w="6350">
-            <a:solidFill>
-              <a:srgbClr val="D5DBE1"/>
-            </a:solidFill>
-          </a:ln>
-        </p:spPr>
-        <p:style>
-          <a:lnRef idx="1">
-            <a:schemeClr val="accent1"/>
-          </a:lnRef>
-          <a:fillRef idx="3">
-            <a:schemeClr val="accent1"/>
-          </a:fillRef>
-          <a:effectRef idx="2">
-            <a:schemeClr val="accent1"/>
-          </a:effectRef>
-          <a:fontRef idx="minor">
-            <a:schemeClr val="lt1"/>
-          </a:fontRef>
-        </p:style>
-        <p:txBody>
-          <a:bodyPr rtlCol="0" anchor="ctr"/>
-          <a:lstStyle/>
-          <a:p>
-            <a:pPr algn="ctr"/>
-          </a:p>
-        </p:txBody>
-      </p:sp>
-      <p:sp>
-        <p:nvSpPr>
-          <p:cNvPr id="48" name="TextBox 47"/>
+          <a:bodyPr rtlCol="0" anchor="ctr" lIns="0" rIns="0" tIns="0" bIns="0"/>
+          <a:lstStyle/>
+          <a:p>
+            <a:pPr algn="ctr">
+              <a:defRPr sz="1000" b="1">
+                <a:solidFill>
+                  <a:srgbClr val="FFFFFF"/>
+                </a:solidFill>
+                <a:latin typeface="Calibri"/>
+              </a:defRPr>
+            </a:pPr>
+            <a:r>
+              <a:t>7</a:t>
+            </a:r>
+          </a:p>
+        </p:txBody>
+      </p:sp>
+      <p:sp>
+        <p:nvSpPr>
+          <p:cNvPr id="54" name="TextBox 53"/>
           <p:cNvSpPr txBox="1"/>
           <p:nvPr/>
         </p:nvSpPr>
         <p:spPr>
           <a:xfrm>
-            <a:off x="731520" y="3794760"/>
-            <a:ext cx="3474720" cy="420624"/>
+            <a:off x="10603839" y="5916168"/>
+            <a:ext cx="841248" cy="420624"/>
           </a:xfrm>
           <a:prstGeom prst="rect">
             <a:avLst/>
@@ -5144,7 +5425,10 @@
           </a:bodyPr>
           <a:lstStyle/>
           <a:p>
-            <a:pPr algn="l">
+            <a:pPr>
+              <a:spcAft>
+                <a:spcPts val="200"/>
+              </a:spcAft>
               <a:defRPr sz="900" b="1">
                 <a:solidFill>
                   <a:srgbClr val="1B2A4A"/>
@@ -5153,35 +5437,12 @@
               </a:defRPr>
             </a:pPr>
             <a:r>
-              <a:t>Splittrad avtals- och leverantörsinformation</a:t>
-            </a:r>
-          </a:p>
-        </p:txBody>
-      </p:sp>
-      <p:sp>
-        <p:nvSpPr>
-          <p:cNvPr id="49" name="TextBox 48"/>
-          <p:cNvSpPr txBox="1"/>
-          <p:nvPr/>
-        </p:nvSpPr>
-        <p:spPr>
-          <a:xfrm>
-            <a:off x="4297680" y="3794760"/>
-            <a:ext cx="7086600" cy="420624"/>
-          </a:xfrm>
-          <a:prstGeom prst="rect">
-            <a:avLst/>
-          </a:prstGeom>
-          <a:noFill/>
-        </p:spPr>
-        <p:txBody>
-          <a:bodyPr wrap="square">
-            <a:spAutoFit/>
-          </a:bodyPr>
-          <a:lstStyle/>
-          <a:p>
-            <a:pPr algn="l">
-              <a:defRPr sz="800" b="0">
+              <a:t>Splittrad data för budget, prognos och uppföljning</a:t>
+            </a:r>
+          </a:p>
+          <a:p>
+            <a:pPr>
+              <a:defRPr sz="750">
                 <a:solidFill>
                   <a:srgbClr val="666666"/>
                 </a:solidFill>
@@ -5189,1210 +5450,6 @@
               </a:defRPr>
             </a:pPr>
             <a:r>
-              <a:t>Ingen sammanhållen koppling mellan inköp, avtal och ekonomi försvårar spårbarhet och uppföljning.</a:t>
-            </a:r>
-          </a:p>
-        </p:txBody>
-      </p:sp>
-      <p:sp>
-        <p:nvSpPr>
-          <p:cNvPr id="50" name="Oval 49"/>
-          <p:cNvSpPr/>
-          <p:nvPr/>
-        </p:nvSpPr>
-        <p:spPr>
-          <a:xfrm>
-            <a:off x="228600" y="4489704"/>
-            <a:ext cx="274320" cy="274320"/>
-          </a:xfrm>
-          <a:prstGeom prst="ellipse">
-            <a:avLst/>
-          </a:prstGeom>
-          <a:solidFill>
-            <a:srgbClr val="F39C12"/>
-          </a:solidFill>
-          <a:ln>
-            <a:noFill/>
-          </a:ln>
-        </p:spPr>
-        <p:style>
-          <a:lnRef idx="1">
-            <a:schemeClr val="accent1"/>
-          </a:lnRef>
-          <a:fillRef idx="3">
-            <a:schemeClr val="accent1"/>
-          </a:fillRef>
-          <a:effectRef idx="2">
-            <a:schemeClr val="accent1"/>
-          </a:effectRef>
-          <a:fontRef idx="minor">
-            <a:schemeClr val="lt1"/>
-          </a:fontRef>
-        </p:style>
-        <p:txBody>
-          <a:bodyPr rtlCol="0" anchor="ctr" lIns="0" rIns="0" tIns="0" bIns="0"/>
-          <a:lstStyle/>
-          <a:p>
-            <a:pPr algn="ctr">
-              <a:defRPr sz="900" b="1">
-                <a:solidFill>
-                  <a:srgbClr val="FFFFFF"/>
-                </a:solidFill>
-                <a:latin typeface="Calibri"/>
-              </a:defRPr>
-            </a:pPr>
-            <a:r>
-              <a:t>4</a:t>
-            </a:r>
-          </a:p>
-        </p:txBody>
-      </p:sp>
-      <p:sp>
-        <p:nvSpPr>
-          <p:cNvPr id="51" name="Rectangle 50"/>
-          <p:cNvSpPr/>
-          <p:nvPr/>
-        </p:nvSpPr>
-        <p:spPr>
-          <a:xfrm>
-            <a:off x="3425799" y="4343400"/>
-            <a:ext cx="6748272" cy="36576"/>
-          </a:xfrm>
-          <a:prstGeom prst="rect">
-            <a:avLst/>
-          </a:prstGeom>
-          <a:solidFill>
-            <a:srgbClr val="F39C12"/>
-          </a:solidFill>
-          <a:ln>
-            <a:noFill/>
-          </a:ln>
-        </p:spPr>
-        <p:style>
-          <a:lnRef idx="1">
-            <a:schemeClr val="accent1"/>
-          </a:lnRef>
-          <a:fillRef idx="3">
-            <a:schemeClr val="accent1"/>
-          </a:fillRef>
-          <a:effectRef idx="2">
-            <a:schemeClr val="accent1"/>
-          </a:effectRef>
-          <a:fontRef idx="minor">
-            <a:schemeClr val="lt1"/>
-          </a:fontRef>
-        </p:style>
-        <p:txBody>
-          <a:bodyPr rtlCol="0" anchor="ctr"/>
-          <a:lstStyle/>
-          <a:p>
-            <a:pPr algn="ctr"/>
-          </a:p>
-        </p:txBody>
-      </p:sp>
-      <p:sp>
-        <p:nvSpPr>
-          <p:cNvPr id="52" name="Rectangle 51"/>
-          <p:cNvSpPr/>
-          <p:nvPr/>
-        </p:nvSpPr>
-        <p:spPr>
-          <a:xfrm>
-            <a:off x="3425799" y="4315968"/>
-            <a:ext cx="25400" cy="91440"/>
-          </a:xfrm>
-          <a:prstGeom prst="rect">
-            <a:avLst/>
-          </a:prstGeom>
-          <a:solidFill>
-            <a:srgbClr val="F39C12"/>
-          </a:solidFill>
-          <a:ln>
-            <a:noFill/>
-          </a:ln>
-        </p:spPr>
-        <p:style>
-          <a:lnRef idx="1">
-            <a:schemeClr val="accent1"/>
-          </a:lnRef>
-          <a:fillRef idx="3">
-            <a:schemeClr val="accent1"/>
-          </a:fillRef>
-          <a:effectRef idx="2">
-            <a:schemeClr val="accent1"/>
-          </a:effectRef>
-          <a:fontRef idx="minor">
-            <a:schemeClr val="lt1"/>
-          </a:fontRef>
-        </p:style>
-        <p:txBody>
-          <a:bodyPr rtlCol="0" anchor="ctr"/>
-          <a:lstStyle/>
-          <a:p>
-            <a:pPr algn="ctr"/>
-          </a:p>
-        </p:txBody>
-      </p:sp>
-      <p:sp>
-        <p:nvSpPr>
-          <p:cNvPr id="53" name="Rectangle 52"/>
-          <p:cNvSpPr/>
-          <p:nvPr/>
-        </p:nvSpPr>
-        <p:spPr>
-          <a:xfrm>
-            <a:off x="10148671" y="4315968"/>
-            <a:ext cx="25400" cy="91440"/>
-          </a:xfrm>
-          <a:prstGeom prst="rect">
-            <a:avLst/>
-          </a:prstGeom>
-          <a:solidFill>
-            <a:srgbClr val="F39C12"/>
-          </a:solidFill>
-          <a:ln>
-            <a:noFill/>
-          </a:ln>
-        </p:spPr>
-        <p:style>
-          <a:lnRef idx="1">
-            <a:schemeClr val="accent1"/>
-          </a:lnRef>
-          <a:fillRef idx="3">
-            <a:schemeClr val="accent1"/>
-          </a:fillRef>
-          <a:effectRef idx="2">
-            <a:schemeClr val="accent1"/>
-          </a:effectRef>
-          <a:fontRef idx="minor">
-            <a:schemeClr val="lt1"/>
-          </a:fontRef>
-        </p:style>
-        <p:txBody>
-          <a:bodyPr rtlCol="0" anchor="ctr"/>
-          <a:lstStyle/>
-          <a:p>
-            <a:pPr algn="ctr"/>
-          </a:p>
-        </p:txBody>
-      </p:sp>
-      <p:sp>
-        <p:nvSpPr>
-          <p:cNvPr id="54" name="Rounded Rectangle 53"/>
-          <p:cNvSpPr/>
-          <p:nvPr/>
-        </p:nvSpPr>
-        <p:spPr>
-          <a:xfrm>
-            <a:off x="594360" y="4398264"/>
-            <a:ext cx="10972800" cy="493776"/>
-          </a:xfrm>
-          <a:prstGeom prst="roundRect">
-            <a:avLst>
-              <a:gd name="adj" fmla="val 6000"/>
-            </a:avLst>
-          </a:prstGeom>
-          <a:solidFill>
-            <a:srgbClr val="F2F2F2"/>
-          </a:solidFill>
-          <a:ln w="6350">
-            <a:solidFill>
-              <a:srgbClr val="D5DBE1"/>
-            </a:solidFill>
-          </a:ln>
-        </p:spPr>
-        <p:style>
-          <a:lnRef idx="1">
-            <a:schemeClr val="accent1"/>
-          </a:lnRef>
-          <a:fillRef idx="3">
-            <a:schemeClr val="accent1"/>
-          </a:fillRef>
-          <a:effectRef idx="2">
-            <a:schemeClr val="accent1"/>
-          </a:effectRef>
-          <a:fontRef idx="minor">
-            <a:schemeClr val="lt1"/>
-          </a:fontRef>
-        </p:style>
-        <p:txBody>
-          <a:bodyPr rtlCol="0" anchor="ctr"/>
-          <a:lstStyle/>
-          <a:p>
-            <a:pPr algn="ctr"/>
-          </a:p>
-        </p:txBody>
-      </p:sp>
-      <p:sp>
-        <p:nvSpPr>
-          <p:cNvPr id="55" name="TextBox 54"/>
-          <p:cNvSpPr txBox="1"/>
-          <p:nvPr/>
-        </p:nvSpPr>
-        <p:spPr>
-          <a:xfrm>
-            <a:off x="731520" y="4434840"/>
-            <a:ext cx="3474720" cy="420624"/>
-          </a:xfrm>
-          <a:prstGeom prst="rect">
-            <a:avLst/>
-          </a:prstGeom>
-          <a:noFill/>
-        </p:spPr>
-        <p:txBody>
-          <a:bodyPr wrap="square">
-            <a:spAutoFit/>
-          </a:bodyPr>
-          <a:lstStyle/>
-          <a:p>
-            <a:pPr algn="l">
-              <a:defRPr sz="900" b="1">
-                <a:solidFill>
-                  <a:srgbClr val="1B2A4A"/>
-                </a:solidFill>
-                <a:latin typeface="Calibri"/>
-              </a:defRPr>
-            </a:pPr>
-            <a:r>
-              <a:t>Manuella och svårt överblickbara arbetsflöden</a:t>
-            </a:r>
-          </a:p>
-        </p:txBody>
-      </p:sp>
-      <p:sp>
-        <p:nvSpPr>
-          <p:cNvPr id="56" name="TextBox 55"/>
-          <p:cNvSpPr txBox="1"/>
-          <p:nvPr/>
-        </p:nvSpPr>
-        <p:spPr>
-          <a:xfrm>
-            <a:off x="4297680" y="4434840"/>
-            <a:ext cx="7086600" cy="420624"/>
-          </a:xfrm>
-          <a:prstGeom prst="rect">
-            <a:avLst/>
-          </a:prstGeom>
-          <a:noFill/>
-        </p:spPr>
-        <p:txBody>
-          <a:bodyPr wrap="square">
-            <a:spAutoFit/>
-          </a:bodyPr>
-          <a:lstStyle/>
-          <a:p>
-            <a:pPr algn="l">
-              <a:defRPr sz="800" b="0">
-                <a:solidFill>
-                  <a:srgbClr val="666666"/>
-                </a:solidFill>
-                <a:latin typeface="Calibri"/>
-              </a:defRPr>
-            </a:pPr>
-            <a:r>
-              <a:t>Excel, mejl, Teams och personberoende arbetssätt försvårar översikt, status och skalbarhet.</a:t>
-            </a:r>
-          </a:p>
-        </p:txBody>
-      </p:sp>
-      <p:sp>
-        <p:nvSpPr>
-          <p:cNvPr id="57" name="Oval 56"/>
-          <p:cNvSpPr/>
-          <p:nvPr/>
-        </p:nvSpPr>
-        <p:spPr>
-          <a:xfrm>
-            <a:off x="228600" y="5129784"/>
-            <a:ext cx="274320" cy="274320"/>
-          </a:xfrm>
-          <a:prstGeom prst="ellipse">
-            <a:avLst/>
-          </a:prstGeom>
-          <a:solidFill>
-            <a:srgbClr val="E67E22"/>
-          </a:solidFill>
-          <a:ln>
-            <a:noFill/>
-          </a:ln>
-        </p:spPr>
-        <p:style>
-          <a:lnRef idx="1">
-            <a:schemeClr val="accent1"/>
-          </a:lnRef>
-          <a:fillRef idx="3">
-            <a:schemeClr val="accent1"/>
-          </a:fillRef>
-          <a:effectRef idx="2">
-            <a:schemeClr val="accent1"/>
-          </a:effectRef>
-          <a:fontRef idx="minor">
-            <a:schemeClr val="lt1"/>
-          </a:fontRef>
-        </p:style>
-        <p:txBody>
-          <a:bodyPr rtlCol="0" anchor="ctr" lIns="0" rIns="0" tIns="0" bIns="0"/>
-          <a:lstStyle/>
-          <a:p>
-            <a:pPr algn="ctr">
-              <a:defRPr sz="900" b="1">
-                <a:solidFill>
-                  <a:srgbClr val="FFFFFF"/>
-                </a:solidFill>
-                <a:latin typeface="Calibri"/>
-              </a:defRPr>
-            </a:pPr>
-            <a:r>
-              <a:t>5</a:t>
-            </a:r>
-          </a:p>
-        </p:txBody>
-      </p:sp>
-      <p:sp>
-        <p:nvSpPr>
-          <p:cNvPr id="58" name="Rectangle 57"/>
-          <p:cNvSpPr/>
-          <p:nvPr/>
-        </p:nvSpPr>
-        <p:spPr>
-          <a:xfrm>
-            <a:off x="4833975" y="4983480"/>
-            <a:ext cx="6748272" cy="36576"/>
-          </a:xfrm>
-          <a:prstGeom prst="rect">
-            <a:avLst/>
-          </a:prstGeom>
-          <a:solidFill>
-            <a:srgbClr val="E67E22"/>
-          </a:solidFill>
-          <a:ln>
-            <a:noFill/>
-          </a:ln>
-        </p:spPr>
-        <p:style>
-          <a:lnRef idx="1">
-            <a:schemeClr val="accent1"/>
-          </a:lnRef>
-          <a:fillRef idx="3">
-            <a:schemeClr val="accent1"/>
-          </a:fillRef>
-          <a:effectRef idx="2">
-            <a:schemeClr val="accent1"/>
-          </a:effectRef>
-          <a:fontRef idx="minor">
-            <a:schemeClr val="lt1"/>
-          </a:fontRef>
-        </p:style>
-        <p:txBody>
-          <a:bodyPr rtlCol="0" anchor="ctr"/>
-          <a:lstStyle/>
-          <a:p>
-            <a:pPr algn="ctr"/>
-          </a:p>
-        </p:txBody>
-      </p:sp>
-      <p:sp>
-        <p:nvSpPr>
-          <p:cNvPr id="59" name="Rectangle 58"/>
-          <p:cNvSpPr/>
-          <p:nvPr/>
-        </p:nvSpPr>
-        <p:spPr>
-          <a:xfrm>
-            <a:off x="4833975" y="4956048"/>
-            <a:ext cx="25400" cy="91440"/>
-          </a:xfrm>
-          <a:prstGeom prst="rect">
-            <a:avLst/>
-          </a:prstGeom>
-          <a:solidFill>
-            <a:srgbClr val="E67E22"/>
-          </a:solidFill>
-          <a:ln>
-            <a:noFill/>
-          </a:ln>
-        </p:spPr>
-        <p:style>
-          <a:lnRef idx="1">
-            <a:schemeClr val="accent1"/>
-          </a:lnRef>
-          <a:fillRef idx="3">
-            <a:schemeClr val="accent1"/>
-          </a:fillRef>
-          <a:effectRef idx="2">
-            <a:schemeClr val="accent1"/>
-          </a:effectRef>
-          <a:fontRef idx="minor">
-            <a:schemeClr val="lt1"/>
-          </a:fontRef>
-        </p:style>
-        <p:txBody>
-          <a:bodyPr rtlCol="0" anchor="ctr"/>
-          <a:lstStyle/>
-          <a:p>
-            <a:pPr algn="ctr"/>
-          </a:p>
-        </p:txBody>
-      </p:sp>
-      <p:sp>
-        <p:nvSpPr>
-          <p:cNvPr id="60" name="Rectangle 59"/>
-          <p:cNvSpPr/>
-          <p:nvPr/>
-        </p:nvSpPr>
-        <p:spPr>
-          <a:xfrm>
-            <a:off x="11556847" y="4956048"/>
-            <a:ext cx="25400" cy="91440"/>
-          </a:xfrm>
-          <a:prstGeom prst="rect">
-            <a:avLst/>
-          </a:prstGeom>
-          <a:solidFill>
-            <a:srgbClr val="E67E22"/>
-          </a:solidFill>
-          <a:ln>
-            <a:noFill/>
-          </a:ln>
-        </p:spPr>
-        <p:style>
-          <a:lnRef idx="1">
-            <a:schemeClr val="accent1"/>
-          </a:lnRef>
-          <a:fillRef idx="3">
-            <a:schemeClr val="accent1"/>
-          </a:fillRef>
-          <a:effectRef idx="2">
-            <a:schemeClr val="accent1"/>
-          </a:effectRef>
-          <a:fontRef idx="minor">
-            <a:schemeClr val="lt1"/>
-          </a:fontRef>
-        </p:style>
-        <p:txBody>
-          <a:bodyPr rtlCol="0" anchor="ctr"/>
-          <a:lstStyle/>
-          <a:p>
-            <a:pPr algn="ctr"/>
-          </a:p>
-        </p:txBody>
-      </p:sp>
-      <p:sp>
-        <p:nvSpPr>
-          <p:cNvPr id="61" name="Rounded Rectangle 60"/>
-          <p:cNvSpPr/>
-          <p:nvPr/>
-        </p:nvSpPr>
-        <p:spPr>
-          <a:xfrm>
-            <a:off x="594360" y="5038344"/>
-            <a:ext cx="10972800" cy="493776"/>
-          </a:xfrm>
-          <a:prstGeom prst="roundRect">
-            <a:avLst>
-              <a:gd name="adj" fmla="val 6000"/>
-            </a:avLst>
-          </a:prstGeom>
-          <a:solidFill>
-            <a:srgbClr val="F2F2F2"/>
-          </a:solidFill>
-          <a:ln w="6350">
-            <a:solidFill>
-              <a:srgbClr val="D5DBE1"/>
-            </a:solidFill>
-          </a:ln>
-        </p:spPr>
-        <p:style>
-          <a:lnRef idx="1">
-            <a:schemeClr val="accent1"/>
-          </a:lnRef>
-          <a:fillRef idx="3">
-            <a:schemeClr val="accent1"/>
-          </a:fillRef>
-          <a:effectRef idx="2">
-            <a:schemeClr val="accent1"/>
-          </a:effectRef>
-          <a:fontRef idx="minor">
-            <a:schemeClr val="lt1"/>
-          </a:fontRef>
-        </p:style>
-        <p:txBody>
-          <a:bodyPr rtlCol="0" anchor="ctr"/>
-          <a:lstStyle/>
-          <a:p>
-            <a:pPr algn="ctr"/>
-          </a:p>
-        </p:txBody>
-      </p:sp>
-      <p:sp>
-        <p:nvSpPr>
-          <p:cNvPr id="62" name="TextBox 61"/>
-          <p:cNvSpPr txBox="1"/>
-          <p:nvPr/>
-        </p:nvSpPr>
-        <p:spPr>
-          <a:xfrm>
-            <a:off x="731520" y="5074920"/>
-            <a:ext cx="3474720" cy="420624"/>
-          </a:xfrm>
-          <a:prstGeom prst="rect">
-            <a:avLst/>
-          </a:prstGeom>
-          <a:noFill/>
-        </p:spPr>
-        <p:txBody>
-          <a:bodyPr wrap="square">
-            <a:spAutoFit/>
-          </a:bodyPr>
-          <a:lstStyle/>
-          <a:p>
-            <a:pPr algn="l">
-              <a:defRPr sz="900" b="1">
-                <a:solidFill>
-                  <a:srgbClr val="1B2A4A"/>
-                </a:solidFill>
-                <a:latin typeface="Calibri"/>
-              </a:defRPr>
-            </a:pPr>
-            <a:r>
-              <a:t>Otydliga ansvar och varierande arbetssätt</a:t>
-            </a:r>
-          </a:p>
-        </p:txBody>
-      </p:sp>
-      <p:sp>
-        <p:nvSpPr>
-          <p:cNvPr id="63" name="TextBox 62"/>
-          <p:cNvSpPr txBox="1"/>
-          <p:nvPr/>
-        </p:nvSpPr>
-        <p:spPr>
-          <a:xfrm>
-            <a:off x="4297680" y="5074920"/>
-            <a:ext cx="7086600" cy="420624"/>
-          </a:xfrm>
-          <a:prstGeom prst="rect">
-            <a:avLst/>
-          </a:prstGeom>
-          <a:noFill/>
-        </p:spPr>
-        <p:txBody>
-          <a:bodyPr wrap="square">
-            <a:spAutoFit/>
-          </a:bodyPr>
-          <a:lstStyle/>
-          <a:p>
-            <a:pPr algn="l">
-              <a:defRPr sz="800" b="0">
-                <a:solidFill>
-                  <a:srgbClr val="666666"/>
-                </a:solidFill>
-                <a:latin typeface="Calibri"/>
-              </a:defRPr>
-            </a:pPr>
-            <a:r>
-              <a:t>Roller arbetar olika och ansvar är inte alltid tydligt definierade, vilket försvårar återkoppling och konsekvent hantering.</a:t>
-            </a:r>
-          </a:p>
-        </p:txBody>
-      </p:sp>
-      <p:sp>
-        <p:nvSpPr>
-          <p:cNvPr id="64" name="Oval 63"/>
-          <p:cNvSpPr/>
-          <p:nvPr/>
-        </p:nvSpPr>
-        <p:spPr>
-          <a:xfrm>
-            <a:off x="228600" y="5769864"/>
-            <a:ext cx="274320" cy="274320"/>
-          </a:xfrm>
-          <a:prstGeom prst="ellipse">
-            <a:avLst/>
-          </a:prstGeom>
-          <a:solidFill>
-            <a:srgbClr val="D35400"/>
-          </a:solidFill>
-          <a:ln>
-            <a:noFill/>
-          </a:ln>
-        </p:spPr>
-        <p:style>
-          <a:lnRef idx="1">
-            <a:schemeClr val="accent1"/>
-          </a:lnRef>
-          <a:fillRef idx="3">
-            <a:schemeClr val="accent1"/>
-          </a:fillRef>
-          <a:effectRef idx="2">
-            <a:schemeClr val="accent1"/>
-          </a:effectRef>
-          <a:fontRef idx="minor">
-            <a:schemeClr val="lt1"/>
-          </a:fontRef>
-        </p:style>
-        <p:txBody>
-          <a:bodyPr rtlCol="0" anchor="ctr" lIns="0" rIns="0" tIns="0" bIns="0"/>
-          <a:lstStyle/>
-          <a:p>
-            <a:pPr algn="ctr">
-              <a:defRPr sz="900" b="1">
-                <a:solidFill>
-                  <a:srgbClr val="FFFFFF"/>
-                </a:solidFill>
-                <a:latin typeface="Calibri"/>
-              </a:defRPr>
-            </a:pPr>
-            <a:r>
-              <a:t>6</a:t>
-            </a:r>
-          </a:p>
-        </p:txBody>
-      </p:sp>
-      <p:sp>
-        <p:nvSpPr>
-          <p:cNvPr id="65" name="Rectangle 64"/>
-          <p:cNvSpPr/>
-          <p:nvPr/>
-        </p:nvSpPr>
-        <p:spPr>
-          <a:xfrm>
-            <a:off x="6242151" y="5623560"/>
-            <a:ext cx="5340096" cy="36576"/>
-          </a:xfrm>
-          <a:prstGeom prst="rect">
-            <a:avLst/>
-          </a:prstGeom>
-          <a:solidFill>
-            <a:srgbClr val="D35400"/>
-          </a:solidFill>
-          <a:ln>
-            <a:noFill/>
-          </a:ln>
-        </p:spPr>
-        <p:style>
-          <a:lnRef idx="1">
-            <a:schemeClr val="accent1"/>
-          </a:lnRef>
-          <a:fillRef idx="3">
-            <a:schemeClr val="accent1"/>
-          </a:fillRef>
-          <a:effectRef idx="2">
-            <a:schemeClr val="accent1"/>
-          </a:effectRef>
-          <a:fontRef idx="minor">
-            <a:schemeClr val="lt1"/>
-          </a:fontRef>
-        </p:style>
-        <p:txBody>
-          <a:bodyPr rtlCol="0" anchor="ctr"/>
-          <a:lstStyle/>
-          <a:p>
-            <a:pPr algn="ctr"/>
-          </a:p>
-        </p:txBody>
-      </p:sp>
-      <p:sp>
-        <p:nvSpPr>
-          <p:cNvPr id="66" name="Rectangle 65"/>
-          <p:cNvSpPr/>
-          <p:nvPr/>
-        </p:nvSpPr>
-        <p:spPr>
-          <a:xfrm>
-            <a:off x="6242151" y="5596128"/>
-            <a:ext cx="25400" cy="91440"/>
-          </a:xfrm>
-          <a:prstGeom prst="rect">
-            <a:avLst/>
-          </a:prstGeom>
-          <a:solidFill>
-            <a:srgbClr val="D35400"/>
-          </a:solidFill>
-          <a:ln>
-            <a:noFill/>
-          </a:ln>
-        </p:spPr>
-        <p:style>
-          <a:lnRef idx="1">
-            <a:schemeClr val="accent1"/>
-          </a:lnRef>
-          <a:fillRef idx="3">
-            <a:schemeClr val="accent1"/>
-          </a:fillRef>
-          <a:effectRef idx="2">
-            <a:schemeClr val="accent1"/>
-          </a:effectRef>
-          <a:fontRef idx="minor">
-            <a:schemeClr val="lt1"/>
-          </a:fontRef>
-        </p:style>
-        <p:txBody>
-          <a:bodyPr rtlCol="0" anchor="ctr"/>
-          <a:lstStyle/>
-          <a:p>
-            <a:pPr algn="ctr"/>
-          </a:p>
-        </p:txBody>
-      </p:sp>
-      <p:sp>
-        <p:nvSpPr>
-          <p:cNvPr id="67" name="Rectangle 66"/>
-          <p:cNvSpPr/>
-          <p:nvPr/>
-        </p:nvSpPr>
-        <p:spPr>
-          <a:xfrm>
-            <a:off x="11556847" y="5596128"/>
-            <a:ext cx="25400" cy="91440"/>
-          </a:xfrm>
-          <a:prstGeom prst="rect">
-            <a:avLst/>
-          </a:prstGeom>
-          <a:solidFill>
-            <a:srgbClr val="D35400"/>
-          </a:solidFill>
-          <a:ln>
-            <a:noFill/>
-          </a:ln>
-        </p:spPr>
-        <p:style>
-          <a:lnRef idx="1">
-            <a:schemeClr val="accent1"/>
-          </a:lnRef>
-          <a:fillRef idx="3">
-            <a:schemeClr val="accent1"/>
-          </a:fillRef>
-          <a:effectRef idx="2">
-            <a:schemeClr val="accent1"/>
-          </a:effectRef>
-          <a:fontRef idx="minor">
-            <a:schemeClr val="lt1"/>
-          </a:fontRef>
-        </p:style>
-        <p:txBody>
-          <a:bodyPr rtlCol="0" anchor="ctr"/>
-          <a:lstStyle/>
-          <a:p>
-            <a:pPr algn="ctr"/>
-          </a:p>
-        </p:txBody>
-      </p:sp>
-      <p:sp>
-        <p:nvSpPr>
-          <p:cNvPr id="68" name="Rounded Rectangle 67"/>
-          <p:cNvSpPr/>
-          <p:nvPr/>
-        </p:nvSpPr>
-        <p:spPr>
-          <a:xfrm>
-            <a:off x="594360" y="5678424"/>
-            <a:ext cx="10972800" cy="493776"/>
-          </a:xfrm>
-          <a:prstGeom prst="roundRect">
-            <a:avLst>
-              <a:gd name="adj" fmla="val 6000"/>
-            </a:avLst>
-          </a:prstGeom>
-          <a:solidFill>
-            <a:srgbClr val="F2F2F2"/>
-          </a:solidFill>
-          <a:ln w="6350">
-            <a:solidFill>
-              <a:srgbClr val="D5DBE1"/>
-            </a:solidFill>
-          </a:ln>
-        </p:spPr>
-        <p:style>
-          <a:lnRef idx="1">
-            <a:schemeClr val="accent1"/>
-          </a:lnRef>
-          <a:fillRef idx="3">
-            <a:schemeClr val="accent1"/>
-          </a:fillRef>
-          <a:effectRef idx="2">
-            <a:schemeClr val="accent1"/>
-          </a:effectRef>
-          <a:fontRef idx="minor">
-            <a:schemeClr val="lt1"/>
-          </a:fontRef>
-        </p:style>
-        <p:txBody>
-          <a:bodyPr rtlCol="0" anchor="ctr"/>
-          <a:lstStyle/>
-          <a:p>
-            <a:pPr algn="ctr"/>
-          </a:p>
-        </p:txBody>
-      </p:sp>
-      <p:sp>
-        <p:nvSpPr>
-          <p:cNvPr id="69" name="TextBox 68"/>
-          <p:cNvSpPr txBox="1"/>
-          <p:nvPr/>
-        </p:nvSpPr>
-        <p:spPr>
-          <a:xfrm>
-            <a:off x="731520" y="5715000"/>
-            <a:ext cx="3474720" cy="420624"/>
-          </a:xfrm>
-          <a:prstGeom prst="rect">
-            <a:avLst/>
-          </a:prstGeom>
-          <a:noFill/>
-        </p:spPr>
-        <p:txBody>
-          <a:bodyPr wrap="square">
-            <a:spAutoFit/>
-          </a:bodyPr>
-          <a:lstStyle/>
-          <a:p>
-            <a:pPr algn="l">
-              <a:defRPr sz="900" b="1">
-                <a:solidFill>
-                  <a:srgbClr val="1B2A4A"/>
-                </a:solidFill>
-                <a:latin typeface="Calibri"/>
-              </a:defRPr>
-            </a:pPr>
-            <a:r>
-              <a:t>Kontrollen kommer först vid fakturan</a:t>
-            </a:r>
-          </a:p>
-        </p:txBody>
-      </p:sp>
-      <p:sp>
-        <p:nvSpPr>
-          <p:cNvPr id="70" name="TextBox 69"/>
-          <p:cNvSpPr txBox="1"/>
-          <p:nvPr/>
-        </p:nvSpPr>
-        <p:spPr>
-          <a:xfrm>
-            <a:off x="4297680" y="5715000"/>
-            <a:ext cx="7086600" cy="420624"/>
-          </a:xfrm>
-          <a:prstGeom prst="rect">
-            <a:avLst/>
-          </a:prstGeom>
-          <a:noFill/>
-        </p:spPr>
-        <p:txBody>
-          <a:bodyPr wrap="square">
-            <a:spAutoFit/>
-          </a:bodyPr>
-          <a:lstStyle/>
-          <a:p>
-            <a:pPr algn="l">
-              <a:defRPr sz="800" b="0">
-                <a:solidFill>
-                  <a:srgbClr val="666666"/>
-                </a:solidFill>
-                <a:latin typeface="Calibri"/>
-              </a:defRPr>
-            </a:pPr>
-            <a:r>
-              <a:t>Avvikelser och fel upptäcks sent, vilket gör kontrollen reaktiv och försvårar internkontroll och tidig felupptäckt.</a:t>
-            </a:r>
-          </a:p>
-        </p:txBody>
-      </p:sp>
-      <p:sp>
-        <p:nvSpPr>
-          <p:cNvPr id="71" name="Oval 70"/>
-          <p:cNvSpPr/>
-          <p:nvPr/>
-        </p:nvSpPr>
-        <p:spPr>
-          <a:xfrm>
-            <a:off x="228600" y="6409944"/>
-            <a:ext cx="274320" cy="274320"/>
-          </a:xfrm>
-          <a:prstGeom prst="ellipse">
-            <a:avLst/>
-          </a:prstGeom>
-          <a:solidFill>
-            <a:srgbClr val="C0392B"/>
-          </a:solidFill>
-          <a:ln>
-            <a:noFill/>
-          </a:ln>
-        </p:spPr>
-        <p:style>
-          <a:lnRef idx="1">
-            <a:schemeClr val="accent1"/>
-          </a:lnRef>
-          <a:fillRef idx="3">
-            <a:schemeClr val="accent1"/>
-          </a:fillRef>
-          <a:effectRef idx="2">
-            <a:schemeClr val="accent1"/>
-          </a:effectRef>
-          <a:fontRef idx="minor">
-            <a:schemeClr val="lt1"/>
-          </a:fontRef>
-        </p:style>
-        <p:txBody>
-          <a:bodyPr rtlCol="0" anchor="ctr" lIns="0" rIns="0" tIns="0" bIns="0"/>
-          <a:lstStyle/>
-          <a:p>
-            <a:pPr algn="ctr">
-              <a:defRPr sz="900" b="1">
-                <a:solidFill>
-                  <a:srgbClr val="FFFFFF"/>
-                </a:solidFill>
-                <a:latin typeface="Calibri"/>
-              </a:defRPr>
-            </a:pPr>
-            <a:r>
-              <a:t>7</a:t>
-            </a:r>
-          </a:p>
-        </p:txBody>
-      </p:sp>
-      <p:sp>
-        <p:nvSpPr>
-          <p:cNvPr id="72" name="Rectangle 71"/>
-          <p:cNvSpPr/>
-          <p:nvPr/>
-        </p:nvSpPr>
-        <p:spPr>
-          <a:xfrm>
-            <a:off x="10466679" y="6263640"/>
-            <a:ext cx="1115568" cy="36576"/>
-          </a:xfrm>
-          <a:prstGeom prst="rect">
-            <a:avLst/>
-          </a:prstGeom>
-          <a:solidFill>
-            <a:srgbClr val="C0392B"/>
-          </a:solidFill>
-          <a:ln>
-            <a:noFill/>
-          </a:ln>
-        </p:spPr>
-        <p:style>
-          <a:lnRef idx="1">
-            <a:schemeClr val="accent1"/>
-          </a:lnRef>
-          <a:fillRef idx="3">
-            <a:schemeClr val="accent1"/>
-          </a:fillRef>
-          <a:effectRef idx="2">
-            <a:schemeClr val="accent1"/>
-          </a:effectRef>
-          <a:fontRef idx="minor">
-            <a:schemeClr val="lt1"/>
-          </a:fontRef>
-        </p:style>
-        <p:txBody>
-          <a:bodyPr rtlCol="0" anchor="ctr"/>
-          <a:lstStyle/>
-          <a:p>
-            <a:pPr algn="ctr"/>
-          </a:p>
-        </p:txBody>
-      </p:sp>
-      <p:sp>
-        <p:nvSpPr>
-          <p:cNvPr id="73" name="Rectangle 72"/>
-          <p:cNvSpPr/>
-          <p:nvPr/>
-        </p:nvSpPr>
-        <p:spPr>
-          <a:xfrm>
-            <a:off x="10466679" y="6236208"/>
-            <a:ext cx="25400" cy="91440"/>
-          </a:xfrm>
-          <a:prstGeom prst="rect">
-            <a:avLst/>
-          </a:prstGeom>
-          <a:solidFill>
-            <a:srgbClr val="C0392B"/>
-          </a:solidFill>
-          <a:ln>
-            <a:noFill/>
-          </a:ln>
-        </p:spPr>
-        <p:style>
-          <a:lnRef idx="1">
-            <a:schemeClr val="accent1"/>
-          </a:lnRef>
-          <a:fillRef idx="3">
-            <a:schemeClr val="accent1"/>
-          </a:fillRef>
-          <a:effectRef idx="2">
-            <a:schemeClr val="accent1"/>
-          </a:effectRef>
-          <a:fontRef idx="minor">
-            <a:schemeClr val="lt1"/>
-          </a:fontRef>
-        </p:style>
-        <p:txBody>
-          <a:bodyPr rtlCol="0" anchor="ctr"/>
-          <a:lstStyle/>
-          <a:p>
-            <a:pPr algn="ctr"/>
-          </a:p>
-        </p:txBody>
-      </p:sp>
-      <p:sp>
-        <p:nvSpPr>
-          <p:cNvPr id="74" name="Rectangle 73"/>
-          <p:cNvSpPr/>
-          <p:nvPr/>
-        </p:nvSpPr>
-        <p:spPr>
-          <a:xfrm>
-            <a:off x="11556847" y="6236208"/>
-            <a:ext cx="25400" cy="91440"/>
-          </a:xfrm>
-          <a:prstGeom prst="rect">
-            <a:avLst/>
-          </a:prstGeom>
-          <a:solidFill>
-            <a:srgbClr val="C0392B"/>
-          </a:solidFill>
-          <a:ln>
-            <a:noFill/>
-          </a:ln>
-        </p:spPr>
-        <p:style>
-          <a:lnRef idx="1">
-            <a:schemeClr val="accent1"/>
-          </a:lnRef>
-          <a:fillRef idx="3">
-            <a:schemeClr val="accent1"/>
-          </a:fillRef>
-          <a:effectRef idx="2">
-            <a:schemeClr val="accent1"/>
-          </a:effectRef>
-          <a:fontRef idx="minor">
-            <a:schemeClr val="lt1"/>
-          </a:fontRef>
-        </p:style>
-        <p:txBody>
-          <a:bodyPr rtlCol="0" anchor="ctr"/>
-          <a:lstStyle/>
-          <a:p>
-            <a:pPr algn="ctr"/>
-          </a:p>
-        </p:txBody>
-      </p:sp>
-      <p:sp>
-        <p:nvSpPr>
-          <p:cNvPr id="75" name="Rounded Rectangle 74"/>
-          <p:cNvSpPr/>
-          <p:nvPr/>
-        </p:nvSpPr>
-        <p:spPr>
-          <a:xfrm>
-            <a:off x="594360" y="6318504"/>
-            <a:ext cx="10972800" cy="493776"/>
-          </a:xfrm>
-          <a:prstGeom prst="roundRect">
-            <a:avLst>
-              <a:gd name="adj" fmla="val 6000"/>
-            </a:avLst>
-          </a:prstGeom>
-          <a:solidFill>
-            <a:srgbClr val="F2F2F2"/>
-          </a:solidFill>
-          <a:ln w="6350">
-            <a:solidFill>
-              <a:srgbClr val="D5DBE1"/>
-            </a:solidFill>
-          </a:ln>
-        </p:spPr>
-        <p:style>
-          <a:lnRef idx="1">
-            <a:schemeClr val="accent1"/>
-          </a:lnRef>
-          <a:fillRef idx="3">
-            <a:schemeClr val="accent1"/>
-          </a:fillRef>
-          <a:effectRef idx="2">
-            <a:schemeClr val="accent1"/>
-          </a:effectRef>
-          <a:fontRef idx="minor">
-            <a:schemeClr val="lt1"/>
-          </a:fontRef>
-        </p:style>
-        <p:txBody>
-          <a:bodyPr rtlCol="0" anchor="ctr"/>
-          <a:lstStyle/>
-          <a:p>
-            <a:pPr algn="ctr"/>
-          </a:p>
-        </p:txBody>
-      </p:sp>
-      <p:sp>
-        <p:nvSpPr>
-          <p:cNvPr id="76" name="TextBox 75"/>
-          <p:cNvSpPr txBox="1"/>
-          <p:nvPr/>
-        </p:nvSpPr>
-        <p:spPr>
-          <a:xfrm>
-            <a:off x="731520" y="6355080"/>
-            <a:ext cx="3474720" cy="420624"/>
-          </a:xfrm>
-          <a:prstGeom prst="rect">
-            <a:avLst/>
-          </a:prstGeom>
-          <a:noFill/>
-        </p:spPr>
-        <p:txBody>
-          <a:bodyPr wrap="square">
-            <a:spAutoFit/>
-          </a:bodyPr>
-          <a:lstStyle/>
-          <a:p>
-            <a:pPr algn="l">
-              <a:defRPr sz="900" b="1">
-                <a:solidFill>
-                  <a:srgbClr val="1B2A4A"/>
-                </a:solidFill>
-                <a:latin typeface="Calibri"/>
-              </a:defRPr>
-            </a:pPr>
-            <a:r>
-              <a:t>Splittrad data för budget, prognos och uppföljning</a:t>
-            </a:r>
-          </a:p>
-        </p:txBody>
-      </p:sp>
-      <p:sp>
-        <p:nvSpPr>
-          <p:cNvPr id="77" name="TextBox 76"/>
-          <p:cNvSpPr txBox="1"/>
-          <p:nvPr/>
-        </p:nvSpPr>
-        <p:spPr>
-          <a:xfrm>
-            <a:off x="4297680" y="6355080"/>
-            <a:ext cx="7086600" cy="420624"/>
-          </a:xfrm>
-          <a:prstGeom prst="rect">
-            <a:avLst/>
-          </a:prstGeom>
-          <a:noFill/>
-        </p:spPr>
-        <p:txBody>
-          <a:bodyPr wrap="square">
-            <a:spAutoFit/>
-          </a:bodyPr>
-          <a:lstStyle/>
-          <a:p>
-            <a:pPr algn="l">
-              <a:defRPr sz="800" b="0">
-                <a:solidFill>
-                  <a:srgbClr val="666666"/>
-                </a:solidFill>
-                <a:latin typeface="Calibri"/>
-              </a:defRPr>
-            </a:pPr>
-            <a:r>
               <a:t>Utfall, personal, verksamhet och planering finns i flera system och i Excel, vilket försvårar analys, prognoser och scenarier.</a:t>
             </a:r>
           </a:p>
@@ -6400,7 +5457,7 @@
       </p:sp>
       <p:sp>
         <p:nvSpPr>
-          <p:cNvPr id="78" name="Rectangle 77"/>
+          <p:cNvPr id="55" name="Rectangle 54"/>
           <p:cNvSpPr/>
           <p:nvPr/>
         </p:nvSpPr>
@@ -6443,7 +5500,7 @@
       </p:sp>
       <p:sp>
         <p:nvSpPr>
-          <p:cNvPr id="79" name="TextBox 78"/>
+          <p:cNvPr id="56" name="TextBox 55"/>
           <p:cNvSpPr txBox="1"/>
           <p:nvPr/>
         </p:nvSpPr>
@@ -6479,7 +5536,7 @@
       </p:sp>
       <p:sp>
         <p:nvSpPr>
-          <p:cNvPr id="80" name="TextBox 79"/>
+          <p:cNvPr id="57" name="TextBox 56"/>
           <p:cNvSpPr txBox="1"/>
           <p:nvPr/>
         </p:nvSpPr>

</xml_diff>

<commit_message>
Fix finding 7 text overflow with minimum card width
Cards that span too few process steps now get a minimum width of
5.5 inches, right-anchored to the last relevant step. Also ensures
cards never extend past the left slide margin.

https://claude.ai/code/session_018gqMj21S2CbNTMiwMALF8M
</commit_message>
<xml_diff>
--- a/P2P_Processkarta_Findings.pptx
+++ b/P2P_Processkarta_Findings.pptx
@@ -4299,8 +4299,8 @@
         </p:nvSpPr>
         <p:spPr>
           <a:xfrm>
-            <a:off x="609447" y="2240280"/>
-            <a:ext cx="3931920" cy="530352"/>
+            <a:off x="594360" y="2240280"/>
+            <a:ext cx="3947007" cy="530352"/>
           </a:xfrm>
           <a:prstGeom prst="roundRect">
             <a:avLst>
@@ -4399,8 +4399,8 @@
         </p:nvSpPr>
         <p:spPr>
           <a:xfrm>
-            <a:off x="746607" y="2295144"/>
-            <a:ext cx="1376172" cy="420624"/>
+            <a:off x="731520" y="2295144"/>
+            <a:ext cx="1381452" cy="420624"/>
           </a:xfrm>
           <a:prstGeom prst="rect">
             <a:avLst/>
@@ -4435,8 +4435,8 @@
         </p:nvSpPr>
         <p:spPr>
           <a:xfrm>
-            <a:off x="2259939" y="2295144"/>
-            <a:ext cx="2144268" cy="420624"/>
+            <a:off x="2250132" y="2295144"/>
+            <a:ext cx="2154074" cy="420624"/>
           </a:xfrm>
           <a:prstGeom prst="rect">
             <a:avLst/>
@@ -4471,8 +4471,8 @@
         </p:nvSpPr>
         <p:spPr>
           <a:xfrm>
-            <a:off x="2017623" y="2843784"/>
-            <a:ext cx="2523744" cy="530352"/>
+            <a:off x="594360" y="2843784"/>
+            <a:ext cx="3947007" cy="530352"/>
           </a:xfrm>
           <a:prstGeom prst="roundRect">
             <a:avLst>
@@ -4571,8 +4571,8 @@
         </p:nvSpPr>
         <p:spPr>
           <a:xfrm>
-            <a:off x="2154783" y="2898648"/>
-            <a:ext cx="2249424" cy="420624"/>
+            <a:off x="731520" y="2898648"/>
+            <a:ext cx="1381452" cy="420624"/>
           </a:xfrm>
           <a:prstGeom prst="rect">
             <a:avLst/>
@@ -4585,10 +4585,7 @@
           </a:bodyPr>
           <a:lstStyle/>
           <a:p>
-            <a:pPr>
-              <a:spcAft>
-                <a:spcPts val="200"/>
-              </a:spcAft>
+            <a:pPr algn="l">
               <a:defRPr sz="900" b="1">
                 <a:solidFill>
                   <a:srgbClr val="1B2A4A"/>
@@ -4600,9 +4597,32 @@
               <a:t>Svagt stöd för köp på avtal</a:t>
             </a:r>
           </a:p>
-          <a:p>
-            <a:pPr>
-              <a:defRPr sz="750">
+        </p:txBody>
+      </p:sp>
+      <p:sp>
+        <p:nvSpPr>
+          <p:cNvPr id="36" name="TextBox 35"/>
+          <p:cNvSpPr txBox="1"/>
+          <p:nvPr/>
+        </p:nvSpPr>
+        <p:spPr>
+          <a:xfrm>
+            <a:off x="2250132" y="2898648"/>
+            <a:ext cx="2154074" cy="420624"/>
+          </a:xfrm>
+          <a:prstGeom prst="rect">
+            <a:avLst/>
+          </a:prstGeom>
+          <a:noFill/>
+        </p:spPr>
+        <p:txBody>
+          <a:bodyPr wrap="square">
+            <a:spAutoFit/>
+          </a:bodyPr>
+          <a:lstStyle/>
+          <a:p>
+            <a:pPr algn="l">
+              <a:defRPr sz="800" b="0">
                 <a:solidFill>
                   <a:srgbClr val="666666"/>
                 </a:solidFill>
@@ -4617,7 +4637,7 @@
       </p:sp>
       <p:sp>
         <p:nvSpPr>
-          <p:cNvPr id="36" name="Rounded Rectangle 35"/>
+          <p:cNvPr id="37" name="Rounded Rectangle 36"/>
           <p:cNvSpPr/>
           <p:nvPr/>
         </p:nvSpPr>
@@ -4664,7 +4684,7 @@
       </p:sp>
       <p:sp>
         <p:nvSpPr>
-          <p:cNvPr id="37" name="Oval 36"/>
+          <p:cNvPr id="38" name="Oval 37"/>
           <p:cNvSpPr/>
           <p:nvPr/>
         </p:nvSpPr>
@@ -4717,7 +4737,7 @@
       </p:sp>
       <p:sp>
         <p:nvSpPr>
-          <p:cNvPr id="38" name="TextBox 37"/>
+          <p:cNvPr id="39" name="TextBox 38"/>
           <p:cNvSpPr txBox="1"/>
           <p:nvPr/>
         </p:nvSpPr>
@@ -4753,7 +4773,7 @@
       </p:sp>
       <p:sp>
         <p:nvSpPr>
-          <p:cNvPr id="39" name="TextBox 38"/>
+          <p:cNvPr id="40" name="TextBox 39"/>
           <p:cNvSpPr txBox="1"/>
           <p:nvPr/>
         </p:nvSpPr>
@@ -4789,7 +4809,7 @@
       </p:sp>
       <p:sp>
         <p:nvSpPr>
-          <p:cNvPr id="40" name="Rounded Rectangle 39"/>
+          <p:cNvPr id="41" name="Rounded Rectangle 40"/>
           <p:cNvSpPr/>
           <p:nvPr/>
         </p:nvSpPr>
@@ -4836,7 +4856,7 @@
       </p:sp>
       <p:sp>
         <p:nvSpPr>
-          <p:cNvPr id="41" name="Oval 40"/>
+          <p:cNvPr id="42" name="Oval 41"/>
           <p:cNvSpPr/>
           <p:nvPr/>
         </p:nvSpPr>
@@ -4889,7 +4909,7 @@
       </p:sp>
       <p:sp>
         <p:nvSpPr>
-          <p:cNvPr id="42" name="TextBox 41"/>
+          <p:cNvPr id="43" name="TextBox 42"/>
           <p:cNvSpPr txBox="1"/>
           <p:nvPr/>
         </p:nvSpPr>
@@ -4925,7 +4945,7 @@
       </p:sp>
       <p:sp>
         <p:nvSpPr>
-          <p:cNvPr id="43" name="TextBox 42"/>
+          <p:cNvPr id="44" name="TextBox 43"/>
           <p:cNvSpPr txBox="1"/>
           <p:nvPr/>
         </p:nvSpPr>
@@ -4961,7 +4981,7 @@
       </p:sp>
       <p:sp>
         <p:nvSpPr>
-          <p:cNvPr id="44" name="Rounded Rectangle 43"/>
+          <p:cNvPr id="45" name="Rounded Rectangle 44"/>
           <p:cNvSpPr/>
           <p:nvPr/>
         </p:nvSpPr>
@@ -5008,7 +5028,7 @@
       </p:sp>
       <p:sp>
         <p:nvSpPr>
-          <p:cNvPr id="45" name="Oval 44"/>
+          <p:cNvPr id="46" name="Oval 45"/>
           <p:cNvSpPr/>
           <p:nvPr/>
         </p:nvSpPr>
@@ -5061,7 +5081,7 @@
       </p:sp>
       <p:sp>
         <p:nvSpPr>
-          <p:cNvPr id="46" name="TextBox 45"/>
+          <p:cNvPr id="47" name="TextBox 46"/>
           <p:cNvSpPr txBox="1"/>
           <p:nvPr/>
         </p:nvSpPr>
@@ -5097,7 +5117,7 @@
       </p:sp>
       <p:sp>
         <p:nvSpPr>
-          <p:cNvPr id="47" name="TextBox 46"/>
+          <p:cNvPr id="48" name="TextBox 47"/>
           <p:cNvSpPr txBox="1"/>
           <p:nvPr/>
         </p:nvSpPr>
@@ -5133,7 +5153,7 @@
       </p:sp>
       <p:sp>
         <p:nvSpPr>
-          <p:cNvPr id="48" name="Rounded Rectangle 47"/>
+          <p:cNvPr id="49" name="Rounded Rectangle 48"/>
           <p:cNvSpPr/>
           <p:nvPr/>
         </p:nvSpPr>
@@ -5180,7 +5200,7 @@
       </p:sp>
       <p:sp>
         <p:nvSpPr>
-          <p:cNvPr id="49" name="Oval 48"/>
+          <p:cNvPr id="50" name="Oval 49"/>
           <p:cNvSpPr/>
           <p:nvPr/>
         </p:nvSpPr>
@@ -5233,7 +5253,7 @@
       </p:sp>
       <p:sp>
         <p:nvSpPr>
-          <p:cNvPr id="50" name="TextBox 49"/>
+          <p:cNvPr id="51" name="TextBox 50"/>
           <p:cNvSpPr txBox="1"/>
           <p:nvPr/>
         </p:nvSpPr>
@@ -5269,7 +5289,7 @@
       </p:sp>
       <p:sp>
         <p:nvSpPr>
-          <p:cNvPr id="51" name="TextBox 50"/>
+          <p:cNvPr id="52" name="TextBox 51"/>
           <p:cNvSpPr txBox="1"/>
           <p:nvPr/>
         </p:nvSpPr>
@@ -5305,14 +5325,14 @@
       </p:sp>
       <p:sp>
         <p:nvSpPr>
-          <p:cNvPr id="52" name="Rounded Rectangle 51"/>
+          <p:cNvPr id="53" name="Rounded Rectangle 52"/>
           <p:cNvSpPr/>
           <p:nvPr/>
         </p:nvSpPr>
         <p:spPr>
           <a:xfrm>
-            <a:off x="10466679" y="5861304"/>
-            <a:ext cx="1115568" cy="530352"/>
+            <a:off x="6553047" y="5861304"/>
+            <a:ext cx="5029200" cy="530352"/>
           </a:xfrm>
           <a:prstGeom prst="roundRect">
             <a:avLst>
@@ -5352,7 +5372,7 @@
       </p:sp>
       <p:sp>
         <p:nvSpPr>
-          <p:cNvPr id="53" name="Oval 52"/>
+          <p:cNvPr id="54" name="Oval 53"/>
           <p:cNvSpPr/>
           <p:nvPr/>
         </p:nvSpPr>
@@ -5405,14 +5425,14 @@
       </p:sp>
       <p:sp>
         <p:nvSpPr>
-          <p:cNvPr id="54" name="TextBox 53"/>
+          <p:cNvPr id="55" name="TextBox 54"/>
           <p:cNvSpPr txBox="1"/>
           <p:nvPr/>
         </p:nvSpPr>
         <p:spPr>
           <a:xfrm>
-            <a:off x="10603839" y="5916168"/>
-            <a:ext cx="841248" cy="420624"/>
+            <a:off x="6690207" y="5916168"/>
+            <a:ext cx="1760220" cy="420624"/>
           </a:xfrm>
           <a:prstGeom prst="rect">
             <a:avLst/>
@@ -5425,10 +5445,7 @@
           </a:bodyPr>
           <a:lstStyle/>
           <a:p>
-            <a:pPr>
-              <a:spcAft>
-                <a:spcPts val="200"/>
-              </a:spcAft>
+            <a:pPr algn="l">
               <a:defRPr sz="900" b="1">
                 <a:solidFill>
                   <a:srgbClr val="1B2A4A"/>
@@ -5440,9 +5457,32 @@
               <a:t>Splittrad data för budget, prognos och uppföljning</a:t>
             </a:r>
           </a:p>
-          <a:p>
-            <a:pPr>
-              <a:defRPr sz="750">
+        </p:txBody>
+      </p:sp>
+      <p:sp>
+        <p:nvSpPr>
+          <p:cNvPr id="56" name="TextBox 55"/>
+          <p:cNvSpPr txBox="1"/>
+          <p:nvPr/>
+        </p:nvSpPr>
+        <p:spPr>
+          <a:xfrm>
+            <a:off x="8587587" y="5916168"/>
+            <a:ext cx="2857500" cy="420624"/>
+          </a:xfrm>
+          <a:prstGeom prst="rect">
+            <a:avLst/>
+          </a:prstGeom>
+          <a:noFill/>
+        </p:spPr>
+        <p:txBody>
+          <a:bodyPr wrap="square">
+            <a:spAutoFit/>
+          </a:bodyPr>
+          <a:lstStyle/>
+          <a:p>
+            <a:pPr algn="l">
+              <a:defRPr sz="800" b="0">
                 <a:solidFill>
                   <a:srgbClr val="666666"/>
                 </a:solidFill>
@@ -5457,7 +5497,7 @@
       </p:sp>
       <p:sp>
         <p:nvSpPr>
-          <p:cNvPr id="55" name="Rectangle 54"/>
+          <p:cNvPr id="57" name="Rectangle 56"/>
           <p:cNvSpPr/>
           <p:nvPr/>
         </p:nvSpPr>
@@ -5500,7 +5540,7 @@
       </p:sp>
       <p:sp>
         <p:nvSpPr>
-          <p:cNvPr id="56" name="TextBox 55"/>
+          <p:cNvPr id="58" name="TextBox 57"/>
           <p:cNvSpPr txBox="1"/>
           <p:nvPr/>
         </p:nvSpPr>
@@ -5536,7 +5576,7 @@
       </p:sp>
       <p:sp>
         <p:nvSpPr>
-          <p:cNvPr id="57" name="TextBox 56"/>
+          <p:cNvPr id="59" name="TextBox 58"/>
           <p:cNvSpPr txBox="1"/>
           <p:nvPr/>
         </p:nvSpPr>

</xml_diff>

<commit_message>
Move Uppföljning from process step to full-width bar beneath flow
Uppföljning is now a continuous horizontal bar spanning all 7 process
steps, reflecting that it runs across the entire P2P process rather
than being a sequential step. Finding 7 spans the full width aligned
with this bar.

https://claude.ai/code/session_018gqMj21S2CbNTMiwMALF8M
</commit_message>
<xml_diff>
--- a/P2P_Processkarta_Findings.pptx
+++ b/P2P_Processkarta_Findings.pptx
@@ -3262,8 +3262,8 @@
         </p:nvSpPr>
         <p:spPr>
           <a:xfrm>
-            <a:off x="609447" y="1325880"/>
-            <a:ext cx="1115568" cy="658368"/>
+            <a:off x="1057503" y="1234440"/>
+            <a:ext cx="1188720" cy="658368"/>
           </a:xfrm>
           <a:prstGeom prst="roundRect">
             <a:avLst>
@@ -3321,7 +3321,7 @@
         </p:nvSpPr>
         <p:spPr>
           <a:xfrm>
-            <a:off x="1727015" y="1527048"/>
+            <a:off x="2248223" y="1435608"/>
             <a:ext cx="288608" cy="256032"/>
           </a:xfrm>
           <a:prstGeom prst="chevron">
@@ -3364,8 +3364,8 @@
         </p:nvSpPr>
         <p:spPr>
           <a:xfrm>
-            <a:off x="2017623" y="1325880"/>
-            <a:ext cx="1115568" cy="658368"/>
+            <a:off x="2538831" y="1234440"/>
+            <a:ext cx="1188720" cy="658368"/>
           </a:xfrm>
           <a:prstGeom prst="roundRect">
             <a:avLst>
@@ -3423,7 +3423,7 @@
         </p:nvSpPr>
         <p:spPr>
           <a:xfrm>
-            <a:off x="3135191" y="1527048"/>
+            <a:off x="3729551" y="1435608"/>
             <a:ext cx="288608" cy="256032"/>
           </a:xfrm>
           <a:prstGeom prst="chevron">
@@ -3466,8 +3466,8 @@
         </p:nvSpPr>
         <p:spPr>
           <a:xfrm>
-            <a:off x="3425799" y="1325880"/>
-            <a:ext cx="1115568" cy="658368"/>
+            <a:off x="4020159" y="1234440"/>
+            <a:ext cx="1188720" cy="658368"/>
           </a:xfrm>
           <a:prstGeom prst="roundRect">
             <a:avLst>
@@ -3521,7 +3521,7 @@
         </p:nvSpPr>
         <p:spPr>
           <a:xfrm>
-            <a:off x="4543367" y="1527048"/>
+            <a:off x="5210879" y="1435608"/>
             <a:ext cx="288608" cy="256032"/>
           </a:xfrm>
           <a:prstGeom prst="chevron">
@@ -3564,8 +3564,8 @@
         </p:nvSpPr>
         <p:spPr>
           <a:xfrm>
-            <a:off x="4833975" y="1325880"/>
-            <a:ext cx="1115568" cy="658368"/>
+            <a:off x="5501487" y="1234440"/>
+            <a:ext cx="1188720" cy="658368"/>
           </a:xfrm>
           <a:prstGeom prst="roundRect">
             <a:avLst>
@@ -3619,7 +3619,7 @@
         </p:nvSpPr>
         <p:spPr>
           <a:xfrm>
-            <a:off x="5951543" y="1527048"/>
+            <a:off x="6692207" y="1435608"/>
             <a:ext cx="288608" cy="256032"/>
           </a:xfrm>
           <a:prstGeom prst="chevron">
@@ -3662,8 +3662,8 @@
         </p:nvSpPr>
         <p:spPr>
           <a:xfrm>
-            <a:off x="6242151" y="1325880"/>
-            <a:ext cx="1115568" cy="658368"/>
+            <a:off x="6982815" y="1234440"/>
+            <a:ext cx="1188720" cy="658368"/>
           </a:xfrm>
           <a:prstGeom prst="roundRect">
             <a:avLst>
@@ -3717,7 +3717,7 @@
         </p:nvSpPr>
         <p:spPr>
           <a:xfrm>
-            <a:off x="7359719" y="1527048"/>
+            <a:off x="8173535" y="1435608"/>
             <a:ext cx="288608" cy="256032"/>
           </a:xfrm>
           <a:prstGeom prst="chevron">
@@ -3760,8 +3760,8 @@
         </p:nvSpPr>
         <p:spPr>
           <a:xfrm>
-            <a:off x="7650327" y="1325880"/>
-            <a:ext cx="1115568" cy="658368"/>
+            <a:off x="8464143" y="1234440"/>
+            <a:ext cx="1188720" cy="658368"/>
           </a:xfrm>
           <a:prstGeom prst="roundRect">
             <a:avLst>
@@ -3815,7 +3815,7 @@
         </p:nvSpPr>
         <p:spPr>
           <a:xfrm>
-            <a:off x="8767895" y="1527048"/>
+            <a:off x="9654863" y="1435608"/>
             <a:ext cx="288608" cy="256032"/>
           </a:xfrm>
           <a:prstGeom prst="chevron">
@@ -3858,8 +3858,8 @@
         </p:nvSpPr>
         <p:spPr>
           <a:xfrm>
-            <a:off x="9058503" y="1325880"/>
-            <a:ext cx="1115568" cy="658368"/>
+            <a:off x="9945471" y="1234440"/>
+            <a:ext cx="1188720" cy="658368"/>
           </a:xfrm>
           <a:prstGeom prst="roundRect">
             <a:avLst>
@@ -3907,61 +3907,18 @@
       </p:sp>
       <p:sp>
         <p:nvSpPr>
-          <p:cNvPr id="19" name="Chevron 18"/>
+          <p:cNvPr id="19" name="Rounded Rectangle 18"/>
           <p:cNvSpPr/>
           <p:nvPr/>
         </p:nvSpPr>
         <p:spPr>
           <a:xfrm>
-            <a:off x="10176071" y="1527048"/>
-            <a:ext cx="288608" cy="256032"/>
-          </a:xfrm>
-          <a:prstGeom prst="chevron">
-            <a:avLst/>
-          </a:prstGeom>
-          <a:solidFill>
-            <a:srgbClr val="B0B8C4"/>
-          </a:solidFill>
-          <a:ln>
-            <a:noFill/>
-          </a:ln>
-        </p:spPr>
-        <p:style>
-          <a:lnRef idx="1">
-            <a:schemeClr val="accent1"/>
-          </a:lnRef>
-          <a:fillRef idx="3">
-            <a:schemeClr val="accent1"/>
-          </a:fillRef>
-          <a:effectRef idx="2">
-            <a:schemeClr val="accent1"/>
-          </a:effectRef>
-          <a:fontRef idx="minor">
-            <a:schemeClr val="lt1"/>
-          </a:fontRef>
-        </p:style>
-        <p:txBody>
-          <a:bodyPr rtlCol="0" anchor="ctr"/>
-          <a:lstStyle/>
-          <a:p>
-            <a:pPr algn="ctr"/>
-          </a:p>
-        </p:txBody>
-      </p:sp>
-      <p:sp>
-        <p:nvSpPr>
-          <p:cNvPr id="20" name="Rounded Rectangle 19"/>
-          <p:cNvSpPr/>
-          <p:nvPr/>
-        </p:nvSpPr>
-        <p:spPr>
-          <a:xfrm>
-            <a:off x="10466679" y="1325880"/>
-            <a:ext cx="1115568" cy="658368"/>
+            <a:off x="1057503" y="2057400"/>
+            <a:ext cx="10076688" cy="347472"/>
           </a:xfrm>
           <a:prstGeom prst="roundRect">
             <a:avLst>
-              <a:gd name="adj" fmla="val 12000"/>
+              <a:gd name="adj" fmla="val 15000"/>
             </a:avLst>
           </a:prstGeom>
           <a:solidFill>
@@ -3990,7 +3947,7 @@
           <a:lstStyle/>
           <a:p>
             <a:pPr algn="ctr">
-              <a:defRPr sz="900" b="1">
+              <a:defRPr sz="1000" b="1">
                 <a:solidFill>
                   <a:srgbClr val="FFFFFF"/>
                 </a:solidFill>
@@ -4005,302 +3962,14 @@
       </p:sp>
       <p:sp>
         <p:nvSpPr>
-          <p:cNvPr id="21" name="TextBox 20"/>
-          <p:cNvSpPr txBox="1"/>
-          <p:nvPr/>
-        </p:nvSpPr>
-        <p:spPr>
-          <a:xfrm>
-            <a:off x="609447" y="2002536"/>
-            <a:ext cx="1115568" cy="182880"/>
-          </a:xfrm>
-          <a:prstGeom prst="rect">
-            <a:avLst/>
-          </a:prstGeom>
-          <a:noFill/>
-        </p:spPr>
-        <p:txBody>
-          <a:bodyPr wrap="square">
-            <a:spAutoFit/>
-          </a:bodyPr>
-          <a:lstStyle/>
-          <a:p>
-            <a:pPr algn="ctr">
-              <a:defRPr sz="700" b="0">
-                <a:solidFill>
-                  <a:srgbClr val="666666"/>
-                </a:solidFill>
-                <a:latin typeface="Calibri"/>
-              </a:defRPr>
-            </a:pPr>
-            <a:r>
-              <a:t>1</a:t>
-            </a:r>
-          </a:p>
-        </p:txBody>
-      </p:sp>
-      <p:sp>
-        <p:nvSpPr>
-          <p:cNvPr id="22" name="TextBox 21"/>
-          <p:cNvSpPr txBox="1"/>
-          <p:nvPr/>
-        </p:nvSpPr>
-        <p:spPr>
-          <a:xfrm>
-            <a:off x="2017623" y="2002536"/>
-            <a:ext cx="1115568" cy="182880"/>
-          </a:xfrm>
-          <a:prstGeom prst="rect">
-            <a:avLst/>
-          </a:prstGeom>
-          <a:noFill/>
-        </p:spPr>
-        <p:txBody>
-          <a:bodyPr wrap="square">
-            <a:spAutoFit/>
-          </a:bodyPr>
-          <a:lstStyle/>
-          <a:p>
-            <a:pPr algn="ctr">
-              <a:defRPr sz="700" b="0">
-                <a:solidFill>
-                  <a:srgbClr val="666666"/>
-                </a:solidFill>
-                <a:latin typeface="Calibri"/>
-              </a:defRPr>
-            </a:pPr>
-            <a:r>
-              <a:t>2</a:t>
-            </a:r>
-          </a:p>
-        </p:txBody>
-      </p:sp>
-      <p:sp>
-        <p:nvSpPr>
-          <p:cNvPr id="23" name="TextBox 22"/>
-          <p:cNvSpPr txBox="1"/>
-          <p:nvPr/>
-        </p:nvSpPr>
-        <p:spPr>
-          <a:xfrm>
-            <a:off x="3425799" y="2002536"/>
-            <a:ext cx="1115568" cy="182880"/>
-          </a:xfrm>
-          <a:prstGeom prst="rect">
-            <a:avLst/>
-          </a:prstGeom>
-          <a:noFill/>
-        </p:spPr>
-        <p:txBody>
-          <a:bodyPr wrap="square">
-            <a:spAutoFit/>
-          </a:bodyPr>
-          <a:lstStyle/>
-          <a:p>
-            <a:pPr algn="ctr">
-              <a:defRPr sz="700" b="0">
-                <a:solidFill>
-                  <a:srgbClr val="666666"/>
-                </a:solidFill>
-                <a:latin typeface="Calibri"/>
-              </a:defRPr>
-            </a:pPr>
-            <a:r>
-              <a:t>3</a:t>
-            </a:r>
-          </a:p>
-        </p:txBody>
-      </p:sp>
-      <p:sp>
-        <p:nvSpPr>
-          <p:cNvPr id="24" name="TextBox 23"/>
-          <p:cNvSpPr txBox="1"/>
-          <p:nvPr/>
-        </p:nvSpPr>
-        <p:spPr>
-          <a:xfrm>
-            <a:off x="4833975" y="2002536"/>
-            <a:ext cx="1115568" cy="182880"/>
-          </a:xfrm>
-          <a:prstGeom prst="rect">
-            <a:avLst/>
-          </a:prstGeom>
-          <a:noFill/>
-        </p:spPr>
-        <p:txBody>
-          <a:bodyPr wrap="square">
-            <a:spAutoFit/>
-          </a:bodyPr>
-          <a:lstStyle/>
-          <a:p>
-            <a:pPr algn="ctr">
-              <a:defRPr sz="700" b="0">
-                <a:solidFill>
-                  <a:srgbClr val="666666"/>
-                </a:solidFill>
-                <a:latin typeface="Calibri"/>
-              </a:defRPr>
-            </a:pPr>
-            <a:r>
-              <a:t>4</a:t>
-            </a:r>
-          </a:p>
-        </p:txBody>
-      </p:sp>
-      <p:sp>
-        <p:nvSpPr>
-          <p:cNvPr id="25" name="TextBox 24"/>
-          <p:cNvSpPr txBox="1"/>
-          <p:nvPr/>
-        </p:nvSpPr>
-        <p:spPr>
-          <a:xfrm>
-            <a:off x="6242151" y="2002536"/>
-            <a:ext cx="1115568" cy="182880"/>
-          </a:xfrm>
-          <a:prstGeom prst="rect">
-            <a:avLst/>
-          </a:prstGeom>
-          <a:noFill/>
-        </p:spPr>
-        <p:txBody>
-          <a:bodyPr wrap="square">
-            <a:spAutoFit/>
-          </a:bodyPr>
-          <a:lstStyle/>
-          <a:p>
-            <a:pPr algn="ctr">
-              <a:defRPr sz="700" b="0">
-                <a:solidFill>
-                  <a:srgbClr val="666666"/>
-                </a:solidFill>
-                <a:latin typeface="Calibri"/>
-              </a:defRPr>
-            </a:pPr>
-            <a:r>
-              <a:t>5</a:t>
-            </a:r>
-          </a:p>
-        </p:txBody>
-      </p:sp>
-      <p:sp>
-        <p:nvSpPr>
-          <p:cNvPr id="26" name="TextBox 25"/>
-          <p:cNvSpPr txBox="1"/>
-          <p:nvPr/>
-        </p:nvSpPr>
-        <p:spPr>
-          <a:xfrm>
-            <a:off x="7650327" y="2002536"/>
-            <a:ext cx="1115568" cy="182880"/>
-          </a:xfrm>
-          <a:prstGeom prst="rect">
-            <a:avLst/>
-          </a:prstGeom>
-          <a:noFill/>
-        </p:spPr>
-        <p:txBody>
-          <a:bodyPr wrap="square">
-            <a:spAutoFit/>
-          </a:bodyPr>
-          <a:lstStyle/>
-          <a:p>
-            <a:pPr algn="ctr">
-              <a:defRPr sz="700" b="0">
-                <a:solidFill>
-                  <a:srgbClr val="666666"/>
-                </a:solidFill>
-                <a:latin typeface="Calibri"/>
-              </a:defRPr>
-            </a:pPr>
-            <a:r>
-              <a:t>6</a:t>
-            </a:r>
-          </a:p>
-        </p:txBody>
-      </p:sp>
-      <p:sp>
-        <p:nvSpPr>
-          <p:cNvPr id="27" name="TextBox 26"/>
-          <p:cNvSpPr txBox="1"/>
-          <p:nvPr/>
-        </p:nvSpPr>
-        <p:spPr>
-          <a:xfrm>
-            <a:off x="9058503" y="2002536"/>
-            <a:ext cx="1115568" cy="182880"/>
-          </a:xfrm>
-          <a:prstGeom prst="rect">
-            <a:avLst/>
-          </a:prstGeom>
-          <a:noFill/>
-        </p:spPr>
-        <p:txBody>
-          <a:bodyPr wrap="square">
-            <a:spAutoFit/>
-          </a:bodyPr>
-          <a:lstStyle/>
-          <a:p>
-            <a:pPr algn="ctr">
-              <a:defRPr sz="700" b="0">
-                <a:solidFill>
-                  <a:srgbClr val="666666"/>
-                </a:solidFill>
-                <a:latin typeface="Calibri"/>
-              </a:defRPr>
-            </a:pPr>
-            <a:r>
-              <a:t>7</a:t>
-            </a:r>
-          </a:p>
-        </p:txBody>
-      </p:sp>
-      <p:sp>
-        <p:nvSpPr>
-          <p:cNvPr id="28" name="TextBox 27"/>
-          <p:cNvSpPr txBox="1"/>
-          <p:nvPr/>
-        </p:nvSpPr>
-        <p:spPr>
-          <a:xfrm>
-            <a:off x="10466679" y="2002536"/>
-            <a:ext cx="1115568" cy="182880"/>
-          </a:xfrm>
-          <a:prstGeom prst="rect">
-            <a:avLst/>
-          </a:prstGeom>
-          <a:noFill/>
-        </p:spPr>
-        <p:txBody>
-          <a:bodyPr wrap="square">
-            <a:spAutoFit/>
-          </a:bodyPr>
-          <a:lstStyle/>
-          <a:p>
-            <a:pPr algn="ctr">
-              <a:defRPr sz="700" b="0">
-                <a:solidFill>
-                  <a:srgbClr val="666666"/>
-                </a:solidFill>
-                <a:latin typeface="Calibri"/>
-              </a:defRPr>
-            </a:pPr>
-            <a:r>
-              <a:t>8</a:t>
-            </a:r>
-          </a:p>
-        </p:txBody>
-      </p:sp>
-      <p:sp>
-        <p:nvSpPr>
-          <p:cNvPr id="29" name="Rounded Rectangle 28"/>
+          <p:cNvPr id="20" name="Rounded Rectangle 19"/>
           <p:cNvSpPr/>
           <p:nvPr/>
         </p:nvSpPr>
         <p:spPr>
           <a:xfrm>
-            <a:off x="594360" y="2240280"/>
-            <a:ext cx="3947007" cy="530352"/>
+            <a:off x="594360" y="2423160"/>
+            <a:ext cx="4614519" cy="530352"/>
           </a:xfrm>
           <a:prstGeom prst="roundRect">
             <a:avLst>
@@ -4340,13 +4009,13 @@
       </p:sp>
       <p:sp>
         <p:nvSpPr>
-          <p:cNvPr id="30" name="Oval 29"/>
+          <p:cNvPr id="21" name="Oval 20"/>
           <p:cNvSpPr/>
           <p:nvPr/>
         </p:nvSpPr>
         <p:spPr>
           <a:xfrm>
-            <a:off x="228600" y="2359152"/>
+            <a:off x="228600" y="2542032"/>
             <a:ext cx="292608" cy="292608"/>
           </a:xfrm>
           <a:prstGeom prst="ellipse">
@@ -4393,14 +4062,14 @@
       </p:sp>
       <p:sp>
         <p:nvSpPr>
-          <p:cNvPr id="31" name="TextBox 30"/>
+          <p:cNvPr id="22" name="TextBox 21"/>
           <p:cNvSpPr txBox="1"/>
           <p:nvPr/>
         </p:nvSpPr>
         <p:spPr>
           <a:xfrm>
-            <a:off x="731520" y="2295144"/>
-            <a:ext cx="1381452" cy="420624"/>
+            <a:off x="731520" y="2478024"/>
+            <a:ext cx="1615081" cy="420624"/>
           </a:xfrm>
           <a:prstGeom prst="rect">
             <a:avLst/>
@@ -4429,14 +4098,14 @@
       </p:sp>
       <p:sp>
         <p:nvSpPr>
-          <p:cNvPr id="32" name="TextBox 31"/>
+          <p:cNvPr id="23" name="TextBox 22"/>
           <p:cNvSpPr txBox="1"/>
           <p:nvPr/>
         </p:nvSpPr>
         <p:spPr>
           <a:xfrm>
-            <a:off x="2250132" y="2295144"/>
-            <a:ext cx="2154074" cy="420624"/>
+            <a:off x="2483761" y="2478024"/>
+            <a:ext cx="2587957" cy="420624"/>
           </a:xfrm>
           <a:prstGeom prst="rect">
             <a:avLst/>
@@ -4465,14 +4134,14 @@
       </p:sp>
       <p:sp>
         <p:nvSpPr>
-          <p:cNvPr id="33" name="Rounded Rectangle 32"/>
+          <p:cNvPr id="24" name="Rounded Rectangle 23"/>
           <p:cNvSpPr/>
           <p:nvPr/>
         </p:nvSpPr>
         <p:spPr>
           <a:xfrm>
-            <a:off x="594360" y="2843784"/>
-            <a:ext cx="3947007" cy="530352"/>
+            <a:off x="594360" y="3026664"/>
+            <a:ext cx="4614519" cy="530352"/>
           </a:xfrm>
           <a:prstGeom prst="roundRect">
             <a:avLst>
@@ -4512,13 +4181,13 @@
       </p:sp>
       <p:sp>
         <p:nvSpPr>
-          <p:cNvPr id="34" name="Oval 33"/>
+          <p:cNvPr id="25" name="Oval 24"/>
           <p:cNvSpPr/>
           <p:nvPr/>
         </p:nvSpPr>
         <p:spPr>
           <a:xfrm>
-            <a:off x="228600" y="2962656"/>
+            <a:off x="228600" y="3145536"/>
             <a:ext cx="292608" cy="292608"/>
           </a:xfrm>
           <a:prstGeom prst="ellipse">
@@ -4565,14 +4234,14 @@
       </p:sp>
       <p:sp>
         <p:nvSpPr>
-          <p:cNvPr id="35" name="TextBox 34"/>
+          <p:cNvPr id="26" name="TextBox 25"/>
           <p:cNvSpPr txBox="1"/>
           <p:nvPr/>
         </p:nvSpPr>
         <p:spPr>
           <a:xfrm>
-            <a:off x="731520" y="2898648"/>
-            <a:ext cx="1381452" cy="420624"/>
+            <a:off x="731520" y="3081528"/>
+            <a:ext cx="1615081" cy="420624"/>
           </a:xfrm>
           <a:prstGeom prst="rect">
             <a:avLst/>
@@ -4601,14 +4270,14 @@
       </p:sp>
       <p:sp>
         <p:nvSpPr>
-          <p:cNvPr id="36" name="TextBox 35"/>
+          <p:cNvPr id="27" name="TextBox 26"/>
           <p:cNvSpPr txBox="1"/>
           <p:nvPr/>
         </p:nvSpPr>
         <p:spPr>
           <a:xfrm>
-            <a:off x="2250132" y="2898648"/>
-            <a:ext cx="2154074" cy="420624"/>
+            <a:off x="2483761" y="3081528"/>
+            <a:ext cx="2587957" cy="420624"/>
           </a:xfrm>
           <a:prstGeom prst="rect">
             <a:avLst/>
@@ -4637,14 +4306,14 @@
       </p:sp>
       <p:sp>
         <p:nvSpPr>
-          <p:cNvPr id="37" name="Rounded Rectangle 36"/>
+          <p:cNvPr id="28" name="Rounded Rectangle 27"/>
           <p:cNvSpPr/>
           <p:nvPr/>
         </p:nvSpPr>
         <p:spPr>
           <a:xfrm>
-            <a:off x="2017623" y="3447288"/>
-            <a:ext cx="9564624" cy="530352"/>
+            <a:off x="2538831" y="3630168"/>
+            <a:ext cx="8595360" cy="530352"/>
           </a:xfrm>
           <a:prstGeom prst="roundRect">
             <a:avLst>
@@ -4684,13 +4353,13 @@
       </p:sp>
       <p:sp>
         <p:nvSpPr>
-          <p:cNvPr id="38" name="Oval 37"/>
+          <p:cNvPr id="29" name="Oval 28"/>
           <p:cNvSpPr/>
           <p:nvPr/>
         </p:nvSpPr>
         <p:spPr>
           <a:xfrm>
-            <a:off x="228600" y="3566160"/>
+            <a:off x="228600" y="3749040"/>
             <a:ext cx="292608" cy="292608"/>
           </a:xfrm>
           <a:prstGeom prst="ellipse">
@@ -4737,14 +4406,14 @@
       </p:sp>
       <p:sp>
         <p:nvSpPr>
-          <p:cNvPr id="39" name="TextBox 38"/>
+          <p:cNvPr id="30" name="TextBox 29"/>
           <p:cNvSpPr txBox="1"/>
           <p:nvPr/>
         </p:nvSpPr>
         <p:spPr>
           <a:xfrm>
-            <a:off x="2154783" y="3502152"/>
-            <a:ext cx="3291840" cy="420624"/>
+            <a:off x="2675991" y="3685032"/>
+            <a:ext cx="3008376" cy="420624"/>
           </a:xfrm>
           <a:prstGeom prst="rect">
             <a:avLst/>
@@ -4773,14 +4442,14 @@
       </p:sp>
       <p:sp>
         <p:nvSpPr>
-          <p:cNvPr id="40" name="TextBox 39"/>
+          <p:cNvPr id="31" name="TextBox 30"/>
           <p:cNvSpPr txBox="1"/>
           <p:nvPr/>
         </p:nvSpPr>
         <p:spPr>
           <a:xfrm>
-            <a:off x="5583783" y="3502152"/>
-            <a:ext cx="5861304" cy="420624"/>
+            <a:off x="5821527" y="3685032"/>
+            <a:ext cx="5175504" cy="420624"/>
           </a:xfrm>
           <a:prstGeom prst="rect">
             <a:avLst/>
@@ -4809,14 +4478,14 @@
       </p:sp>
       <p:sp>
         <p:nvSpPr>
-          <p:cNvPr id="41" name="Rounded Rectangle 40"/>
+          <p:cNvPr id="32" name="Rounded Rectangle 31"/>
           <p:cNvSpPr/>
           <p:nvPr/>
         </p:nvSpPr>
         <p:spPr>
           <a:xfrm>
-            <a:off x="3425799" y="4050792"/>
-            <a:ext cx="6748272" cy="530352"/>
+            <a:off x="4020159" y="4233672"/>
+            <a:ext cx="7114032" cy="530352"/>
           </a:xfrm>
           <a:prstGeom prst="roundRect">
             <a:avLst>
@@ -4856,13 +4525,13 @@
       </p:sp>
       <p:sp>
         <p:nvSpPr>
-          <p:cNvPr id="42" name="Oval 41"/>
+          <p:cNvPr id="33" name="Oval 32"/>
           <p:cNvSpPr/>
           <p:nvPr/>
         </p:nvSpPr>
         <p:spPr>
           <a:xfrm>
-            <a:off x="228600" y="4169664"/>
+            <a:off x="228600" y="4352544"/>
             <a:ext cx="292608" cy="292608"/>
           </a:xfrm>
           <a:prstGeom prst="ellipse">
@@ -4909,14 +4578,14 @@
       </p:sp>
       <p:sp>
         <p:nvSpPr>
-          <p:cNvPr id="43" name="TextBox 42"/>
+          <p:cNvPr id="34" name="TextBox 33"/>
           <p:cNvSpPr txBox="1"/>
           <p:nvPr/>
         </p:nvSpPr>
         <p:spPr>
           <a:xfrm>
-            <a:off x="3562959" y="4105656"/>
-            <a:ext cx="2361895" cy="420624"/>
+            <a:off x="4157319" y="4288536"/>
+            <a:ext cx="2489911" cy="420624"/>
           </a:xfrm>
           <a:prstGeom prst="rect">
             <a:avLst/>
@@ -4945,14 +4614,14 @@
       </p:sp>
       <p:sp>
         <p:nvSpPr>
-          <p:cNvPr id="44" name="TextBox 43"/>
+          <p:cNvPr id="35" name="TextBox 34"/>
           <p:cNvSpPr txBox="1"/>
           <p:nvPr/>
         </p:nvSpPr>
         <p:spPr>
           <a:xfrm>
-            <a:off x="6062014" y="4105656"/>
-            <a:ext cx="3974896" cy="420624"/>
+            <a:off x="6784390" y="4288536"/>
+            <a:ext cx="4212640" cy="420624"/>
           </a:xfrm>
           <a:prstGeom prst="rect">
             <a:avLst/>
@@ -4981,14 +4650,14 @@
       </p:sp>
       <p:sp>
         <p:nvSpPr>
-          <p:cNvPr id="45" name="Rounded Rectangle 44"/>
+          <p:cNvPr id="36" name="Rounded Rectangle 35"/>
           <p:cNvSpPr/>
           <p:nvPr/>
         </p:nvSpPr>
         <p:spPr>
           <a:xfrm>
-            <a:off x="4833975" y="4654296"/>
-            <a:ext cx="6748272" cy="530352"/>
+            <a:off x="5501487" y="4837176"/>
+            <a:ext cx="5632704" cy="530352"/>
           </a:xfrm>
           <a:prstGeom prst="roundRect">
             <a:avLst>
@@ -5028,13 +4697,13 @@
       </p:sp>
       <p:sp>
         <p:nvSpPr>
-          <p:cNvPr id="46" name="Oval 45"/>
+          <p:cNvPr id="37" name="Oval 36"/>
           <p:cNvSpPr/>
           <p:nvPr/>
         </p:nvSpPr>
         <p:spPr>
           <a:xfrm>
-            <a:off x="228600" y="4773168"/>
+            <a:off x="228600" y="4956048"/>
             <a:ext cx="292608" cy="292608"/>
           </a:xfrm>
           <a:prstGeom prst="ellipse">
@@ -5081,14 +4750,14 @@
       </p:sp>
       <p:sp>
         <p:nvSpPr>
-          <p:cNvPr id="47" name="TextBox 46"/>
+          <p:cNvPr id="38" name="TextBox 37"/>
           <p:cNvSpPr txBox="1"/>
           <p:nvPr/>
         </p:nvSpPr>
         <p:spPr>
           <a:xfrm>
-            <a:off x="4971135" y="4709160"/>
-            <a:ext cx="2361895" cy="420624"/>
+            <a:off x="5638647" y="4892040"/>
+            <a:ext cx="1971446" cy="420624"/>
           </a:xfrm>
           <a:prstGeom prst="rect">
             <a:avLst/>
@@ -5117,14 +4786,14 @@
       </p:sp>
       <p:sp>
         <p:nvSpPr>
-          <p:cNvPr id="48" name="TextBox 47"/>
+          <p:cNvPr id="39" name="TextBox 38"/>
           <p:cNvSpPr txBox="1"/>
           <p:nvPr/>
         </p:nvSpPr>
         <p:spPr>
           <a:xfrm>
-            <a:off x="7470190" y="4709160"/>
-            <a:ext cx="3974896" cy="420624"/>
+            <a:off x="7747253" y="4892040"/>
+            <a:ext cx="3249777" cy="420624"/>
           </a:xfrm>
           <a:prstGeom prst="rect">
             <a:avLst/>
@@ -5153,14 +4822,14 @@
       </p:sp>
       <p:sp>
         <p:nvSpPr>
-          <p:cNvPr id="49" name="Rounded Rectangle 48"/>
+          <p:cNvPr id="40" name="Rounded Rectangle 39"/>
           <p:cNvSpPr/>
           <p:nvPr/>
         </p:nvSpPr>
         <p:spPr>
           <a:xfrm>
-            <a:off x="6242151" y="5257800"/>
-            <a:ext cx="5340096" cy="530352"/>
+            <a:off x="6104991" y="5440680"/>
+            <a:ext cx="5029200" cy="530352"/>
           </a:xfrm>
           <a:prstGeom prst="roundRect">
             <a:avLst>
@@ -5200,13 +4869,13 @@
       </p:sp>
       <p:sp>
         <p:nvSpPr>
-          <p:cNvPr id="50" name="Oval 49"/>
+          <p:cNvPr id="41" name="Oval 40"/>
           <p:cNvSpPr/>
           <p:nvPr/>
         </p:nvSpPr>
         <p:spPr>
           <a:xfrm>
-            <a:off x="228600" y="5376672"/>
+            <a:off x="228600" y="5559552"/>
             <a:ext cx="292608" cy="292608"/>
           </a:xfrm>
           <a:prstGeom prst="ellipse">
@@ -5253,14 +4922,14 @@
       </p:sp>
       <p:sp>
         <p:nvSpPr>
-          <p:cNvPr id="51" name="TextBox 50"/>
+          <p:cNvPr id="42" name="TextBox 41"/>
           <p:cNvSpPr txBox="1"/>
           <p:nvPr/>
         </p:nvSpPr>
         <p:spPr>
           <a:xfrm>
-            <a:off x="6379311" y="5312664"/>
-            <a:ext cx="1869033" cy="420624"/>
+            <a:off x="6242151" y="5495544"/>
+            <a:ext cx="1760220" cy="420624"/>
           </a:xfrm>
           <a:prstGeom prst="rect">
             <a:avLst/>
@@ -5289,14 +4958,14 @@
       </p:sp>
       <p:sp>
         <p:nvSpPr>
-          <p:cNvPr id="52" name="TextBox 51"/>
+          <p:cNvPr id="43" name="TextBox 42"/>
           <p:cNvSpPr txBox="1"/>
           <p:nvPr/>
         </p:nvSpPr>
         <p:spPr>
           <a:xfrm>
-            <a:off x="8385505" y="5312664"/>
-            <a:ext cx="3059582" cy="420624"/>
+            <a:off x="8139531" y="5495544"/>
+            <a:ext cx="2857500" cy="420624"/>
           </a:xfrm>
           <a:prstGeom prst="rect">
             <a:avLst/>
@@ -5325,14 +4994,14 @@
       </p:sp>
       <p:sp>
         <p:nvSpPr>
-          <p:cNvPr id="53" name="Rounded Rectangle 52"/>
+          <p:cNvPr id="44" name="Rounded Rectangle 43"/>
           <p:cNvSpPr/>
           <p:nvPr/>
         </p:nvSpPr>
         <p:spPr>
           <a:xfrm>
-            <a:off x="6553047" y="5861304"/>
-            <a:ext cx="5029200" cy="530352"/>
+            <a:off x="1057503" y="6044184"/>
+            <a:ext cx="10076688" cy="530352"/>
           </a:xfrm>
           <a:prstGeom prst="roundRect">
             <a:avLst>
@@ -5372,13 +5041,13 @@
       </p:sp>
       <p:sp>
         <p:nvSpPr>
-          <p:cNvPr id="54" name="Oval 53"/>
+          <p:cNvPr id="45" name="Oval 44"/>
           <p:cNvSpPr/>
           <p:nvPr/>
         </p:nvSpPr>
         <p:spPr>
           <a:xfrm>
-            <a:off x="228600" y="5980176"/>
+            <a:off x="228600" y="6163056"/>
             <a:ext cx="292608" cy="292608"/>
           </a:xfrm>
           <a:prstGeom prst="ellipse">
@@ -5425,14 +5094,14 @@
       </p:sp>
       <p:sp>
         <p:nvSpPr>
-          <p:cNvPr id="55" name="TextBox 54"/>
+          <p:cNvPr id="46" name="TextBox 45"/>
           <p:cNvSpPr txBox="1"/>
           <p:nvPr/>
         </p:nvSpPr>
         <p:spPr>
           <a:xfrm>
-            <a:off x="6690207" y="5916168"/>
-            <a:ext cx="1760220" cy="420624"/>
+            <a:off x="1194663" y="6099048"/>
+            <a:ext cx="3291840" cy="420624"/>
           </a:xfrm>
           <a:prstGeom prst="rect">
             <a:avLst/>
@@ -5461,14 +5130,14 @@
       </p:sp>
       <p:sp>
         <p:nvSpPr>
-          <p:cNvPr id="56" name="TextBox 55"/>
+          <p:cNvPr id="47" name="TextBox 46"/>
           <p:cNvSpPr txBox="1"/>
           <p:nvPr/>
         </p:nvSpPr>
         <p:spPr>
           <a:xfrm>
-            <a:off x="8587587" y="5916168"/>
-            <a:ext cx="2857500" cy="420624"/>
+            <a:off x="4623663" y="6099048"/>
+            <a:ext cx="6373368" cy="420624"/>
           </a:xfrm>
           <a:prstGeom prst="rect">
             <a:avLst/>
@@ -5497,7 +5166,7 @@
       </p:sp>
       <p:sp>
         <p:nvSpPr>
-          <p:cNvPr id="57" name="Rectangle 56"/>
+          <p:cNvPr id="48" name="Rectangle 47"/>
           <p:cNvSpPr/>
           <p:nvPr/>
         </p:nvSpPr>
@@ -5540,7 +5209,7 @@
       </p:sp>
       <p:sp>
         <p:nvSpPr>
-          <p:cNvPr id="58" name="TextBox 57"/>
+          <p:cNvPr id="49" name="TextBox 48"/>
           <p:cNvSpPr txBox="1"/>
           <p:nvPr/>
         </p:nvSpPr>
@@ -5576,7 +5245,7 @@
       </p:sp>
       <p:sp>
         <p:nvSpPr>
-          <p:cNvPr id="59" name="TextBox 58"/>
+          <p:cNvPr id="50" name="TextBox 49"/>
           <p:cNvSpPr txBox="1"/>
           <p:nvPr/>
         </p:nvSpPr>

</xml_diff>